<commit_message>
Record the hosted 14-slide Elite Claims board after the clip fix.
Native PowerPoint renders show complete decision and action copy, including slide 11.

Co-authored-by: Cursor <cursoragent@cursor.com>
</commit_message>
<xml_diff>
--- a/docs/private-beta/hosted-ux-qa/supreme-privacy/Supreme-Privacy-Board.pptx
+++ b/docs/private-beta/hosted-ux-qa/supreme-privacy/Supreme-Privacy-Board.pptx
@@ -2,7 +2,7 @@
 <file path=ppt/presentation.xml><?xml version="1.0" encoding="utf-8"?>
 <p:presentation xmlns:a="http://schemas.openxmlformats.org/drawingml/2006/main" xmlns:r="http://schemas.openxmlformats.org/officeDocument/2006/relationships" xmlns:p="http://schemas.openxmlformats.org/presentationml/2006/main">
   <p:sldMasterIdLst>
-    <p:sldMasterId id="2147483648" r:id="rId13"/>
+    <p:sldMasterId id="2147483648" r:id="rId15"/>
   </p:sldMasterIdLst>
   <p:sldIdLst>
     <p:sldId id="256" r:id="rId1"/>
@@ -17,6 +17,8 @@
     <p:sldId id="265" r:id="rId10"/>
     <p:sldId id="266" r:id="rId11"/>
     <p:sldId id="267" r:id="rId12"/>
+    <p:sldId id="268" r:id="rId13"/>
+    <p:sldId id="269" r:id="rId14"/>
   </p:sldIdLst>
   <p:sldSz cx="12192000" cy="6858000" type="screen16x9"/>
   <p:notesSz cx="6858000" cy="9144000"/>
@@ -944,22 +946,22 @@
       </p:sp>
       <p:sp>
         <p:nvSpPr>
-          <p:cNvPr id="60" name="t60"/>
+          <p:cNvPr id="60" name="n60"/>
           <p:cNvSpPr txBox="1"/>
           <p:nvPr/>
         </p:nvSpPr>
         <p:spPr>
           <a:xfrm>
             <a:off x="420000" y="3200000"/>
-            <a:ext cx="11300000" cy="420000"/>
-          </a:xfrm>
-          <a:prstGeom prst="rect">
-            <a:avLst/>
-          </a:prstGeom>
-          <a:noFill/>
-        </p:spPr>
-        <p:txBody>
-          <a:bodyPr wrap="square" anchor="t" lIns="45720" tIns="22860" rIns="45720" bIns="22860"/>
+            <a:ext cx="11300000" cy="610000"/>
+          </a:xfrm>
+          <a:prstGeom prst="rect">
+            <a:avLst/>
+          </a:prstGeom>
+          <a:noFill/>
+        </p:spPr>
+        <p:txBody>
+          <a:bodyPr wrap="square" anchor="t" lIns="45720" tIns="8000" rIns="45720" bIns="8000"/>
           <a:lstStyle/>
           <a:p>
             <a:pPr algn="l"/>
@@ -970,30 +972,9 @@
                 </a:solidFill>
                 <a:latin typeface="Calibri" pitchFamily="34" charset="0"/>
               </a:rPr>
-              <a:t xml:space="preserve">GAP-00001 Open privacy-related gap: GAP-00001 500.07 is mapped to controls that are not implemented. A gap is remaining work, not a legal co</a:t>
-            </a:r>
-          </a:p>
-        </p:txBody>
-      </p:sp>
-      <p:sp>
-        <p:nvSpPr>
-          <p:cNvPr id="61" name="t61"/>
-          <p:cNvSpPr txBox="1"/>
-          <p:nvPr/>
-        </p:nvSpPr>
-        <p:spPr>
-          <a:xfrm>
-            <a:off x="420000" y="3660000"/>
-            <a:ext cx="11300000" cy="420000"/>
-          </a:xfrm>
-          <a:prstGeom prst="rect">
-            <a:avLst/>
-          </a:prstGeom>
-          <a:noFill/>
-        </p:spPr>
-        <p:txBody>
-          <a:bodyPr wrap="square" anchor="t" lIns="45720" tIns="22860" rIns="45720" bIns="22860"/>
-          <a:lstStyle/>
+              <a:t xml:space="preserve">GAP-00001 Open privacy-related gap: GAP-00001 500.07 is mapped to controls that are not</a:t>
+            </a:r>
+          </a:p>
           <a:p>
             <a:pPr algn="l"/>
             <a:r>
@@ -1003,29 +984,29 @@
                 </a:solidFill>
                 <a:latin typeface="Calibri" pitchFamily="34" charset="0"/>
               </a:rPr>
-              <a:t xml:space="preserve">GAP-00003 Open privacy-related gap: GAP-00003 A.15 is mapped to controls that are not implemented. A gap is remaining work, not a legal conc</a:t>
-            </a:r>
-          </a:p>
-        </p:txBody>
-      </p:sp>
-      <p:sp>
-        <p:nvSpPr>
-          <p:cNvPr id="62" name="t62"/>
-          <p:cNvSpPr txBox="1"/>
-          <p:nvPr/>
-        </p:nvSpPr>
-        <p:spPr>
-          <a:xfrm>
-            <a:off x="420000" y="4120000"/>
-            <a:ext cx="11300000" cy="420000"/>
-          </a:xfrm>
-          <a:prstGeom prst="rect">
-            <a:avLst/>
-          </a:prstGeom>
-          <a:noFill/>
-        </p:spPr>
-        <p:txBody>
-          <a:bodyPr wrap="square" anchor="t" lIns="45720" tIns="22860" rIns="45720" bIns="22860"/>
+              <a:t xml:space="preserve">implemented. A gap is remaining work, not a legal conclusion.</a:t>
+            </a:r>
+          </a:p>
+        </p:txBody>
+      </p:sp>
+      <p:sp>
+        <p:nvSpPr>
+          <p:cNvPr id="61" name="n61"/>
+          <p:cNvSpPr txBox="1"/>
+          <p:nvPr/>
+        </p:nvSpPr>
+        <p:spPr>
+          <a:xfrm>
+            <a:off x="420000" y="3870000"/>
+            <a:ext cx="11300000" cy="610000"/>
+          </a:xfrm>
+          <a:prstGeom prst="rect">
+            <a:avLst/>
+          </a:prstGeom>
+          <a:noFill/>
+        </p:spPr>
+        <p:txBody>
+          <a:bodyPr wrap="square" anchor="t" lIns="45720" tIns="8000" rIns="45720" bIns="8000"/>
           <a:lstStyle/>
           <a:p>
             <a:pPr algn="l"/>
@@ -1036,30 +1017,9 @@
                 </a:solidFill>
                 <a:latin typeface="Calibri" pitchFamily="34" charset="0"/>
               </a:rPr>
-              <a:t xml:space="preserve">GAP-00002 Open privacy-related gap: GAP-00002 500.07 has no current CLEAN evidence. A gap is remaining work, not a legal conclusion.</a:t>
-            </a:r>
-          </a:p>
-        </p:txBody>
-      </p:sp>
-      <p:sp>
-        <p:nvSpPr>
-          <p:cNvPr id="63" name="t63"/>
-          <p:cNvSpPr txBox="1"/>
-          <p:nvPr/>
-        </p:nvSpPr>
-        <p:spPr>
-          <a:xfrm>
-            <a:off x="420000" y="4580000"/>
-            <a:ext cx="11300000" cy="420000"/>
-          </a:xfrm>
-          <a:prstGeom prst="rect">
-            <a:avLst/>
-          </a:prstGeom>
-          <a:noFill/>
-        </p:spPr>
-        <p:txBody>
-          <a:bodyPr wrap="square" anchor="t" lIns="45720" tIns="22860" rIns="45720" bIns="22860"/>
-          <a:lstStyle/>
+              <a:t xml:space="preserve">GAP-00003 Open privacy-related gap: GAP-00003 A.15 is mapped to controls that are not</a:t>
+            </a:r>
+          </a:p>
           <a:p>
             <a:pPr algn="l"/>
             <a:r>
@@ -1069,7 +1029,97 @@
                 </a:solidFill>
                 <a:latin typeface="Calibri" pitchFamily="34" charset="0"/>
               </a:rPr>
-              <a:t xml:space="preserve">GAP-00004 Open privacy-related gap: GAP-00004 A.15 has no current CLEAN evidence. A gap is remaining work, not a legal conclusion.</a:t>
+              <a:t xml:space="preserve">implemented. A gap is remaining work, not a legal conclusion.</a:t>
+            </a:r>
+          </a:p>
+        </p:txBody>
+      </p:sp>
+      <p:sp>
+        <p:nvSpPr>
+          <p:cNvPr id="62" name="n62"/>
+          <p:cNvSpPr txBox="1"/>
+          <p:nvPr/>
+        </p:nvSpPr>
+        <p:spPr>
+          <a:xfrm>
+            <a:off x="420000" y="4540000"/>
+            <a:ext cx="11300000" cy="610000"/>
+          </a:xfrm>
+          <a:prstGeom prst="rect">
+            <a:avLst/>
+          </a:prstGeom>
+          <a:noFill/>
+        </p:spPr>
+        <p:txBody>
+          <a:bodyPr wrap="square" anchor="t" lIns="45720" tIns="8000" rIns="45720" bIns="8000"/>
+          <a:lstStyle/>
+          <a:p>
+            <a:pPr algn="l"/>
+            <a:r>
+              <a:rPr lang="en-US" sz="1300" b="0" dirty="0">
+                <a:solidFill>
+                  <a:srgbClr val="0F172A"/>
+                </a:solidFill>
+                <a:latin typeface="Calibri" pitchFamily="34" charset="0"/>
+              </a:rPr>
+              <a:t xml:space="preserve">GAP-00002 Open privacy-related gap: GAP-00002 500.07 has no current CLEAN evidence. A</a:t>
+            </a:r>
+          </a:p>
+          <a:p>
+            <a:pPr algn="l"/>
+            <a:r>
+              <a:rPr lang="en-US" sz="1300" b="0" dirty="0">
+                <a:solidFill>
+                  <a:srgbClr val="0F172A"/>
+                </a:solidFill>
+                <a:latin typeface="Calibri" pitchFamily="34" charset="0"/>
+              </a:rPr>
+              <a:t xml:space="preserve">gap is remaining work, not a legal conclusion.</a:t>
+            </a:r>
+          </a:p>
+        </p:txBody>
+      </p:sp>
+      <p:sp>
+        <p:nvSpPr>
+          <p:cNvPr id="63" name="n63"/>
+          <p:cNvSpPr txBox="1"/>
+          <p:nvPr/>
+        </p:nvSpPr>
+        <p:spPr>
+          <a:xfrm>
+            <a:off x="420000" y="5210000"/>
+            <a:ext cx="11300000" cy="610000"/>
+          </a:xfrm>
+          <a:prstGeom prst="rect">
+            <a:avLst/>
+          </a:prstGeom>
+          <a:noFill/>
+        </p:spPr>
+        <p:txBody>
+          <a:bodyPr wrap="square" anchor="t" lIns="45720" tIns="8000" rIns="45720" bIns="8000"/>
+          <a:lstStyle/>
+          <a:p>
+            <a:pPr algn="l"/>
+            <a:r>
+              <a:rPr lang="en-US" sz="1300" b="0" dirty="0">
+                <a:solidFill>
+                  <a:srgbClr val="0F172A"/>
+                </a:solidFill>
+                <a:latin typeface="Calibri" pitchFamily="34" charset="0"/>
+              </a:rPr>
+              <a:t xml:space="preserve">GAP-00004 Open privacy-related gap: GAP-00004 A.15 has no current CLEAN evidence. A gap</a:t>
+            </a:r>
+          </a:p>
+          <a:p>
+            <a:pPr algn="l"/>
+            <a:r>
+              <a:rPr lang="en-US" sz="1300" b="0" dirty="0">
+                <a:solidFill>
+                  <a:srgbClr val="0F172A"/>
+                </a:solidFill>
+                <a:latin typeface="Calibri" pitchFamily="34" charset="0"/>
+              </a:rPr>
+              <a:t xml:space="preserve">is remaining work, not a legal conclusion.</a:t>
             </a:r>
           </a:p>
         </p:txBody>
@@ -1166,7 +1216,7 @@
                 </a:solidFill>
                 <a:latin typeface="Calibri" pitchFamily="34" charset="0"/>
               </a:rPr>
-              <a:t xml:space="preserve">10 / 12</a:t>
+              <a:t xml:space="preserve">10 / 14</a:t>
             </a:r>
           </a:p>
         </p:txBody>
@@ -1326,22 +1376,22 @@
       </p:sp>
       <p:sp>
         <p:nvSpPr>
-          <p:cNvPr id="20" name="t20"/>
+          <p:cNvPr id="20" name="n20"/>
           <p:cNvSpPr txBox="1"/>
           <p:nvPr/>
         </p:nvSpPr>
         <p:spPr>
           <a:xfrm>
             <a:off x="420000" y="1680000"/>
-            <a:ext cx="11300000" cy="420000"/>
-          </a:xfrm>
-          <a:prstGeom prst="rect">
-            <a:avLst/>
-          </a:prstGeom>
-          <a:noFill/>
-        </p:spPr>
-        <p:txBody>
-          <a:bodyPr wrap="square" anchor="t" lIns="45720" tIns="22860" rIns="45720" bIns="22860"/>
+            <a:ext cx="11300000" cy="610000"/>
+          </a:xfrm>
+          <a:prstGeom prst="rect">
+            <a:avLst/>
+          </a:prstGeom>
+          <a:noFill/>
+        </p:spPr>
+        <p:txBody>
+          <a:bodyPr wrap="square" anchor="t" lIns="45720" tIns="8000" rIns="45720" bIns="8000"/>
           <a:lstStyle/>
           <a:p>
             <a:pPr algn="l"/>
@@ -1352,30 +1402,9 @@
                 </a:solidFill>
                 <a:latin typeface="Calibri" pitchFamily="34" charset="0"/>
               </a:rPr>
-              <a:t xml:space="preserve">XFR-00001 Transfer requiring review — XFR-00001 US-NY → IE is recorded as review required. This is not a lawfulness finding.</a:t>
-            </a:r>
-          </a:p>
-        </p:txBody>
-      </p:sp>
-      <p:sp>
-        <p:nvSpPr>
-          <p:cNvPr id="21" name="t21"/>
-          <p:cNvSpPr txBox="1"/>
-          <p:nvPr/>
-        </p:nvSpPr>
-        <p:spPr>
-          <a:xfrm>
-            <a:off x="420000" y="2140000"/>
-            <a:ext cx="11300000" cy="420000"/>
-          </a:xfrm>
-          <a:prstGeom prst="rect">
-            <a:avLst/>
-          </a:prstGeom>
-          <a:noFill/>
-        </p:spPr>
-        <p:txBody>
-          <a:bodyPr wrap="square" anchor="t" lIns="45720" tIns="22860" rIns="45720" bIns="22860"/>
-          <a:lstStyle/>
+              <a:t xml:space="preserve">XFR-00001 Transfer requiring review — XFR-00001 US-NY → IE is recorded as review</a:t>
+            </a:r>
+          </a:p>
           <a:p>
             <a:pPr algn="l"/>
             <a:r>
@@ -1385,29 +1414,29 @@
                 </a:solidFill>
                 <a:latin typeface="Calibri" pitchFamily="34" charset="0"/>
               </a:rPr>
-              <a:t xml:space="preserve">XFR-00002 Transfer requiring review — XFR-00002 US-NY → IE is recorded as review required. This is not a lawfulness finding.</a:t>
-            </a:r>
-          </a:p>
-        </p:txBody>
-      </p:sp>
-      <p:sp>
-        <p:nvSpPr>
-          <p:cNvPr id="22" name="t22"/>
-          <p:cNvSpPr txBox="1"/>
-          <p:nvPr/>
-        </p:nvSpPr>
-        <p:spPr>
-          <a:xfrm>
-            <a:off x="420000" y="2600000"/>
-            <a:ext cx="11300000" cy="420000"/>
-          </a:xfrm>
-          <a:prstGeom prst="rect">
-            <a:avLst/>
-          </a:prstGeom>
-          <a:noFill/>
-        </p:spPr>
-        <p:txBody>
-          <a:bodyPr wrap="square" anchor="t" lIns="45720" tIns="22860" rIns="45720" bIns="22860"/>
+              <a:t xml:space="preserve">required. This is not a lawfulness finding.</a:t>
+            </a:r>
+          </a:p>
+        </p:txBody>
+      </p:sp>
+      <p:sp>
+        <p:nvSpPr>
+          <p:cNvPr id="21" name="n21"/>
+          <p:cNvSpPr txBox="1"/>
+          <p:nvPr/>
+        </p:nvSpPr>
+        <p:spPr>
+          <a:xfrm>
+            <a:off x="420000" y="2360000"/>
+            <a:ext cx="11300000" cy="610000"/>
+          </a:xfrm>
+          <a:prstGeom prst="rect">
+            <a:avLst/>
+          </a:prstGeom>
+          <a:noFill/>
+        </p:spPr>
+        <p:txBody>
+          <a:bodyPr wrap="square" anchor="t" lIns="45720" tIns="8000" rIns="45720" bIns="8000"/>
           <a:lstStyle/>
           <a:p>
             <a:pPr algn="l"/>
@@ -1418,30 +1447,9 @@
                 </a:solidFill>
                 <a:latin typeface="Calibri" pitchFamily="34" charset="0"/>
               </a:rPr>
-              <a:t xml:space="preserve">XFR-00003 Transfer requiring review — XFR-00003 US-NY → IE is recorded as review required. This is not a lawfulness finding.</a:t>
-            </a:r>
-          </a:p>
-        </p:txBody>
-      </p:sp>
-      <p:sp>
-        <p:nvSpPr>
-          <p:cNvPr id="23" name="t23"/>
-          <p:cNvSpPr txBox="1"/>
-          <p:nvPr/>
-        </p:nvSpPr>
-        <p:spPr>
-          <a:xfrm>
-            <a:off x="420000" y="3060000"/>
-            <a:ext cx="11300000" cy="420000"/>
-          </a:xfrm>
-          <a:prstGeom prst="rect">
-            <a:avLst/>
-          </a:prstGeom>
-          <a:noFill/>
-        </p:spPr>
-        <p:txBody>
-          <a:bodyPr wrap="square" anchor="t" lIns="45720" tIns="22860" rIns="45720" bIns="22860"/>
-          <a:lstStyle/>
+              <a:t xml:space="preserve">XFR-00002 Transfer requiring review — XFR-00002 US-NY → IE is recorded as review</a:t>
+            </a:r>
+          </a:p>
           <a:p>
             <a:pPr algn="l"/>
             <a:r>
@@ -1451,29 +1459,29 @@
                 </a:solidFill>
                 <a:latin typeface="Calibri" pitchFamily="34" charset="0"/>
               </a:rPr>
-              <a:t xml:space="preserve">XFR-00004 Transfer requiring review — XFR-00004 US-NY → IE is recorded as review required. This is not a lawfulness finding.</a:t>
-            </a:r>
-          </a:p>
-        </p:txBody>
-      </p:sp>
-      <p:sp>
-        <p:nvSpPr>
-          <p:cNvPr id="24" name="t24"/>
-          <p:cNvSpPr txBox="1"/>
-          <p:nvPr/>
-        </p:nvSpPr>
-        <p:spPr>
-          <a:xfrm>
-            <a:off x="420000" y="3520000"/>
-            <a:ext cx="11300000" cy="420000"/>
-          </a:xfrm>
-          <a:prstGeom prst="rect">
-            <a:avLst/>
-          </a:prstGeom>
-          <a:noFill/>
-        </p:spPr>
-        <p:txBody>
-          <a:bodyPr wrap="square" anchor="t" lIns="45720" tIns="22860" rIns="45720" bIns="22860"/>
+              <a:t xml:space="preserve">required. This is not a lawfulness finding.</a:t>
+            </a:r>
+          </a:p>
+        </p:txBody>
+      </p:sp>
+      <p:sp>
+        <p:nvSpPr>
+          <p:cNvPr id="22" name="n22"/>
+          <p:cNvSpPr txBox="1"/>
+          <p:nvPr/>
+        </p:nvSpPr>
+        <p:spPr>
+          <a:xfrm>
+            <a:off x="420000" y="3040000"/>
+            <a:ext cx="11300000" cy="610000"/>
+          </a:xfrm>
+          <a:prstGeom prst="rect">
+            <a:avLst/>
+          </a:prstGeom>
+          <a:noFill/>
+        </p:spPr>
+        <p:txBody>
+          <a:bodyPr wrap="square" anchor="t" lIns="45720" tIns="8000" rIns="45720" bIns="8000"/>
           <a:lstStyle/>
           <a:p>
             <a:pPr algn="l"/>
@@ -1484,7 +1492,154 @@
                 </a:solidFill>
                 <a:latin typeface="Calibri" pitchFamily="34" charset="0"/>
               </a:rPr>
-              <a:t xml:space="preserve">GAP-00001 Open privacy-related gap — GAP-00001 500.07 is mapped to controls that are not implemented. A gap is remaining work, not a legal c</a:t>
+              <a:t xml:space="preserve">XFR-00003 Transfer requiring review — XFR-00003 US-NY → IE is recorded as review</a:t>
+            </a:r>
+          </a:p>
+          <a:p>
+            <a:pPr algn="l"/>
+            <a:r>
+              <a:rPr lang="en-US" sz="1300" b="0" dirty="0">
+                <a:solidFill>
+                  <a:srgbClr val="0F172A"/>
+                </a:solidFill>
+                <a:latin typeface="Calibri" pitchFamily="34" charset="0"/>
+              </a:rPr>
+              <a:t xml:space="preserve">required. This is not a lawfulness finding.</a:t>
+            </a:r>
+          </a:p>
+        </p:txBody>
+      </p:sp>
+      <p:sp>
+        <p:nvSpPr>
+          <p:cNvPr id="23" name="n23"/>
+          <p:cNvSpPr txBox="1"/>
+          <p:nvPr/>
+        </p:nvSpPr>
+        <p:spPr>
+          <a:xfrm>
+            <a:off x="420000" y="3720000"/>
+            <a:ext cx="11300000" cy="610000"/>
+          </a:xfrm>
+          <a:prstGeom prst="rect">
+            <a:avLst/>
+          </a:prstGeom>
+          <a:noFill/>
+        </p:spPr>
+        <p:txBody>
+          <a:bodyPr wrap="square" anchor="t" lIns="45720" tIns="8000" rIns="45720" bIns="8000"/>
+          <a:lstStyle/>
+          <a:p>
+            <a:pPr algn="l"/>
+            <a:r>
+              <a:rPr lang="en-US" sz="1300" b="0" dirty="0">
+                <a:solidFill>
+                  <a:srgbClr val="0F172A"/>
+                </a:solidFill>
+                <a:latin typeface="Calibri" pitchFamily="34" charset="0"/>
+              </a:rPr>
+              <a:t xml:space="preserve">XFR-00004 Transfer requiring review — XFR-00004 US-NY → IE is recorded as review</a:t>
+            </a:r>
+          </a:p>
+          <a:p>
+            <a:pPr algn="l"/>
+            <a:r>
+              <a:rPr lang="en-US" sz="1300" b="0" dirty="0">
+                <a:solidFill>
+                  <a:srgbClr val="0F172A"/>
+                </a:solidFill>
+                <a:latin typeface="Calibri" pitchFamily="34" charset="0"/>
+              </a:rPr>
+              <a:t xml:space="preserve">required. This is not a lawfulness finding.</a:t>
+            </a:r>
+          </a:p>
+        </p:txBody>
+      </p:sp>
+      <p:sp>
+        <p:nvSpPr>
+          <p:cNvPr id="24" name="n24"/>
+          <p:cNvSpPr txBox="1"/>
+          <p:nvPr/>
+        </p:nvSpPr>
+        <p:spPr>
+          <a:xfrm>
+            <a:off x="420000" y="4400000"/>
+            <a:ext cx="11300000" cy="610000"/>
+          </a:xfrm>
+          <a:prstGeom prst="rect">
+            <a:avLst/>
+          </a:prstGeom>
+          <a:noFill/>
+        </p:spPr>
+        <p:txBody>
+          <a:bodyPr wrap="square" anchor="t" lIns="45720" tIns="8000" rIns="45720" bIns="8000"/>
+          <a:lstStyle/>
+          <a:p>
+            <a:pPr algn="l"/>
+            <a:r>
+              <a:rPr lang="en-US" sz="1300" b="0" dirty="0">
+                <a:solidFill>
+                  <a:srgbClr val="0F172A"/>
+                </a:solidFill>
+                <a:latin typeface="Calibri" pitchFamily="34" charset="0"/>
+              </a:rPr>
+              <a:t xml:space="preserve">GAP-00001 Open privacy-related gap — GAP-00001 500.07 is mapped to controls that are not</a:t>
+            </a:r>
+          </a:p>
+          <a:p>
+            <a:pPr algn="l"/>
+            <a:r>
+              <a:rPr lang="en-US" sz="1300" b="0" dirty="0">
+                <a:solidFill>
+                  <a:srgbClr val="0F172A"/>
+                </a:solidFill>
+                <a:latin typeface="Calibri" pitchFamily="34" charset="0"/>
+              </a:rPr>
+              <a:t xml:space="preserve">implemented. A gap is remaining work, not a legal conclusion.</a:t>
+            </a:r>
+          </a:p>
+        </p:txBody>
+      </p:sp>
+      <p:sp>
+        <p:nvSpPr>
+          <p:cNvPr id="25" name="n25"/>
+          <p:cNvSpPr txBox="1"/>
+          <p:nvPr/>
+        </p:nvSpPr>
+        <p:spPr>
+          <a:xfrm>
+            <a:off x="420000" y="5080000"/>
+            <a:ext cx="11300000" cy="610000"/>
+          </a:xfrm>
+          <a:prstGeom prst="rect">
+            <a:avLst/>
+          </a:prstGeom>
+          <a:noFill/>
+        </p:spPr>
+        <p:txBody>
+          <a:bodyPr wrap="square" anchor="t" lIns="45720" tIns="8000" rIns="45720" bIns="8000"/>
+          <a:lstStyle/>
+          <a:p>
+            <a:pPr algn="l"/>
+            <a:r>
+              <a:rPr lang="en-US" sz="1300" b="0" dirty="0">
+                <a:solidFill>
+                  <a:srgbClr val="0F172A"/>
+                </a:solidFill>
+                <a:latin typeface="Calibri" pitchFamily="34" charset="0"/>
+              </a:rPr>
+              <a:t xml:space="preserve">GAP-00003 Open privacy-related gap — GAP-00003 A.15 is mapped to controls that are not</a:t>
+            </a:r>
+          </a:p>
+          <a:p>
+            <a:pPr algn="l"/>
+            <a:r>
+              <a:rPr lang="en-US" sz="1300" b="0" dirty="0">
+                <a:solidFill>
+                  <a:srgbClr val="0F172A"/>
+                </a:solidFill>
+                <a:latin typeface="Calibri" pitchFamily="34" charset="0"/>
+              </a:rPr>
+              <a:t xml:space="preserve">implemented. A gap is remaining work, not a legal conclusion.</a:t>
             </a:r>
           </a:p>
         </p:txBody>
@@ -1581,7 +1736,7 @@
                 </a:solidFill>
                 <a:latin typeface="Calibri" pitchFamily="34" charset="0"/>
               </a:rPr>
-              <a:t xml:space="preserve">11 / 12</a:t>
+              <a:t xml:space="preserve">11 / 14</a:t>
             </a:r>
           </a:p>
         </p:txBody>
@@ -1701,7 +1856,7 @@
                 </a:solidFill>
                 <a:latin typeface="Calibri" pitchFamily="34" charset="0"/>
               </a:rPr>
-              <a:t xml:space="preserve">Priority actions / next 90 days</a:t>
+              <a:t xml:space="preserve">Key decisions required · continued</a:t>
             </a:r>
           </a:p>
         </p:txBody>
@@ -1734,29 +1889,29 @@
                 </a:solidFill>
                 <a:latin typeface="Calibri" pitchFamily="34" charset="0"/>
               </a:rPr>
-              <a:t xml:space="preserve">Taken from the live attention queue. No invented program.</a:t>
-            </a:r>
-          </a:p>
-        </p:txBody>
-      </p:sp>
-      <p:sp>
-        <p:nvSpPr>
-          <p:cNvPr id="20" name="t20"/>
+              <a:t xml:space="preserve">Human-authoritative. Supreme does not issue legal conclusions.</a:t>
+            </a:r>
+          </a:p>
+        </p:txBody>
+      </p:sp>
+      <p:sp>
+        <p:nvSpPr>
+          <p:cNvPr id="20" name="n20"/>
           <p:cNvSpPr txBox="1"/>
           <p:nvPr/>
         </p:nvSpPr>
         <p:spPr>
           <a:xfrm>
             <a:off x="420000" y="1680000"/>
-            <a:ext cx="11300000" cy="420000"/>
-          </a:xfrm>
-          <a:prstGeom prst="rect">
-            <a:avLst/>
-          </a:prstGeom>
-          <a:noFill/>
-        </p:spPr>
-        <p:txBody>
-          <a:bodyPr wrap="square" anchor="t" lIns="45720" tIns="22860" rIns="45720" bIns="22860"/>
+            <a:ext cx="11300000" cy="610000"/>
+          </a:xfrm>
+          <a:prstGeom prst="rect">
+            <a:avLst/>
+          </a:prstGeom>
+          <a:noFill/>
+        </p:spPr>
+        <p:txBody>
+          <a:bodyPr wrap="square" anchor="t" lIns="45720" tIns="8000" rIns="45720" bIns="8000"/>
           <a:lstStyle/>
           <a:p>
             <a:pPr algn="l"/>
@@ -1767,30 +1922,9 @@
                 </a:solidFill>
                 <a:latin typeface="Calibri" pitchFamily="34" charset="0"/>
               </a:rPr>
-              <a:t xml:space="preserve">1. Review XFR-00001 — Transfer requiring review</a:t>
-            </a:r>
-          </a:p>
-        </p:txBody>
-      </p:sp>
-      <p:sp>
-        <p:nvSpPr>
-          <p:cNvPr id="21" name="t21"/>
-          <p:cNvSpPr txBox="1"/>
-          <p:nvPr/>
-        </p:nvSpPr>
-        <p:spPr>
-          <a:xfrm>
-            <a:off x="420000" y="2140000"/>
-            <a:ext cx="11300000" cy="420000"/>
-          </a:xfrm>
-          <a:prstGeom prst="rect">
-            <a:avLst/>
-          </a:prstGeom>
-          <a:noFill/>
-        </p:spPr>
-        <p:txBody>
-          <a:bodyPr wrap="square" anchor="t" lIns="45720" tIns="22860" rIns="45720" bIns="22860"/>
-          <a:lstStyle/>
+              <a:t xml:space="preserve">GAP-00002 Open privacy-related gap — GAP-00002 500.07 has no current CLEAN evidence. A</a:t>
+            </a:r>
+          </a:p>
           <a:p>
             <a:pPr algn="l"/>
             <a:r>
@@ -1800,29 +1934,29 @@
                 </a:solidFill>
                 <a:latin typeface="Calibri" pitchFamily="34" charset="0"/>
               </a:rPr>
-              <a:t xml:space="preserve">2. Review XFR-00002 — Transfer requiring review</a:t>
-            </a:r>
-          </a:p>
-        </p:txBody>
-      </p:sp>
-      <p:sp>
-        <p:nvSpPr>
-          <p:cNvPr id="22" name="t22"/>
-          <p:cNvSpPr txBox="1"/>
-          <p:nvPr/>
-        </p:nvSpPr>
-        <p:spPr>
-          <a:xfrm>
-            <a:off x="420000" y="2600000"/>
-            <a:ext cx="11300000" cy="420000"/>
-          </a:xfrm>
-          <a:prstGeom prst="rect">
-            <a:avLst/>
-          </a:prstGeom>
-          <a:noFill/>
-        </p:spPr>
-        <p:txBody>
-          <a:bodyPr wrap="square" anchor="t" lIns="45720" tIns="22860" rIns="45720" bIns="22860"/>
+              <a:t xml:space="preserve">gap is remaining work, not a legal conclusion.</a:t>
+            </a:r>
+          </a:p>
+        </p:txBody>
+      </p:sp>
+      <p:sp>
+        <p:nvSpPr>
+          <p:cNvPr id="21" name="n21"/>
+          <p:cNvSpPr txBox="1"/>
+          <p:nvPr/>
+        </p:nvSpPr>
+        <p:spPr>
+          <a:xfrm>
+            <a:off x="420000" y="2360000"/>
+            <a:ext cx="11300000" cy="610000"/>
+          </a:xfrm>
+          <a:prstGeom prst="rect">
+            <a:avLst/>
+          </a:prstGeom>
+          <a:noFill/>
+        </p:spPr>
+        <p:txBody>
+          <a:bodyPr wrap="square" anchor="t" lIns="45720" tIns="8000" rIns="45720" bIns="8000"/>
           <a:lstStyle/>
           <a:p>
             <a:pPr algn="l"/>
@@ -1833,30 +1967,9 @@
                 </a:solidFill>
                 <a:latin typeface="Calibri" pitchFamily="34" charset="0"/>
               </a:rPr>
-              <a:t xml:space="preserve">3. Review XFR-00003 — Transfer requiring review</a:t>
-            </a:r>
-          </a:p>
-        </p:txBody>
-      </p:sp>
-      <p:sp>
-        <p:nvSpPr>
-          <p:cNvPr id="23" name="t23"/>
-          <p:cNvSpPr txBox="1"/>
-          <p:nvPr/>
-        </p:nvSpPr>
-        <p:spPr>
-          <a:xfrm>
-            <a:off x="420000" y="3060000"/>
-            <a:ext cx="11300000" cy="420000"/>
-          </a:xfrm>
-          <a:prstGeom prst="rect">
-            <a:avLst/>
-          </a:prstGeom>
-          <a:noFill/>
-        </p:spPr>
-        <p:txBody>
-          <a:bodyPr wrap="square" anchor="t" lIns="45720" tIns="22860" rIns="45720" bIns="22860"/>
-          <a:lstStyle/>
+              <a:t xml:space="preserve">GAP-00004 Open privacy-related gap — GAP-00004 A.15 has no current CLEAN evidence. A gap</a:t>
+            </a:r>
+          </a:p>
           <a:p>
             <a:pPr algn="l"/>
             <a:r>
@@ -1866,73 +1979,7 @@
                 </a:solidFill>
                 <a:latin typeface="Calibri" pitchFamily="34" charset="0"/>
               </a:rPr>
-              <a:t xml:space="preserve">4. Review XFR-00004 — Transfer requiring review</a:t>
-            </a:r>
-          </a:p>
-        </p:txBody>
-      </p:sp>
-      <p:sp>
-        <p:nvSpPr>
-          <p:cNvPr id="24" name="t24"/>
-          <p:cNvSpPr txBox="1"/>
-          <p:nvPr/>
-        </p:nvSpPr>
-        <p:spPr>
-          <a:xfrm>
-            <a:off x="420000" y="3520000"/>
-            <a:ext cx="11300000" cy="420000"/>
-          </a:xfrm>
-          <a:prstGeom prst="rect">
-            <a:avLst/>
-          </a:prstGeom>
-          <a:noFill/>
-        </p:spPr>
-        <p:txBody>
-          <a:bodyPr wrap="square" anchor="t" lIns="45720" tIns="22860" rIns="45720" bIns="22860"/>
-          <a:lstStyle/>
-          <a:p>
-            <a:pPr algn="l"/>
-            <a:r>
-              <a:rPr lang="en-US" sz="1300" b="0" dirty="0">
-                <a:solidFill>
-                  <a:srgbClr val="0F172A"/>
-                </a:solidFill>
-                <a:latin typeface="Calibri" pitchFamily="34" charset="0"/>
-              </a:rPr>
-              <a:t xml:space="preserve">5. Review GAP-00001 — Open privacy-related gap</a:t>
-            </a:r>
-          </a:p>
-        </p:txBody>
-      </p:sp>
-      <p:sp>
-        <p:nvSpPr>
-          <p:cNvPr id="90" name="t90"/>
-          <p:cNvSpPr txBox="1"/>
-          <p:nvPr/>
-        </p:nvSpPr>
-        <p:spPr>
-          <a:xfrm>
-            <a:off x="420000" y="5600000"/>
-            <a:ext cx="11000000" cy="300000"/>
-          </a:xfrm>
-          <a:prstGeom prst="rect">
-            <a:avLst/>
-          </a:prstGeom>
-          <a:noFill/>
-        </p:spPr>
-        <p:txBody>
-          <a:bodyPr wrap="square" anchor="t" lIns="45720" tIns="22860" rIns="45720" bIns="22860"/>
-          <a:lstStyle/>
-          <a:p>
-            <a:pPr algn="l"/>
-            <a:r>
-              <a:rPr lang="en-US" sz="1200" b="0" dirty="0">
-                <a:solidFill>
-                  <a:srgbClr val="64748B"/>
-                </a:solidFill>
-                <a:latin typeface="Calibri" pitchFamily="34" charset="0"/>
-              </a:rPr>
-              <a:t xml:space="preserve">Consent collector remains not configured / manual. No trend available.</a:t>
+              <a:t xml:space="preserve">is remaining work, not a legal conclusion.</a:t>
             </a:r>
           </a:p>
         </p:txBody>
@@ -2029,7 +2076,900 @@
                 </a:solidFill>
                 <a:latin typeface="Calibri" pitchFamily="34" charset="0"/>
               </a:rPr>
-              <a:t xml:space="preserve">12 / 12</a:t>
+              <a:t xml:space="preserve">12 / 14</a:t>
+            </a:r>
+          </a:p>
+        </p:txBody>
+      </p:sp>
+    </p:spTree>
+  </p:cSld>
+  <p:clrMapOvr>
+    <a:masterClrMapping/>
+  </p:clrMapOvr>
+</p:sld>
+</file>
+
+<file path=ppt/slides/slide13.xml><?xml version="1.0" encoding="utf-8"?>
+<p:sld xmlns:a="http://schemas.openxmlformats.org/drawingml/2006/main" xmlns:r="http://schemas.openxmlformats.org/officeDocument/2006/relationships" xmlns:p="http://schemas.openxmlformats.org/presentationml/2006/main">
+  <p:cSld>
+    <p:spTree>
+      <p:nvGrpSpPr>
+        <p:cNvPr id="1" name=""/>
+        <p:cNvGrpSpPr/>
+        <p:nvPr/>
+      </p:nvGrpSpPr>
+      <p:grpSpPr>
+        <a:xfrm>
+          <a:off x="0" y="0"/>
+          <a:ext cx="0" cy="0"/>
+          <a:chOff x="0" y="0"/>
+          <a:chExt cx="0" cy="0"/>
+        </a:xfrm>
+      </p:grpSpPr>
+      <p:sp>
+        <p:nvSpPr>
+          <p:cNvPr id="3" name="bar"/>
+          <p:cNvSpPr/>
+          <p:nvPr/>
+        </p:nvSpPr>
+        <p:spPr>
+          <a:xfrm>
+            <a:off x="0" y="0"/>
+            <a:ext cx="12192000" cy="1180000"/>
+          </a:xfrm>
+          <a:prstGeom prst="roundRect">
+            <a:avLst>
+              <a:gd name="adj" fmla="val 6000"/>
+            </a:avLst>
+          </a:prstGeom>
+          <a:solidFill>
+            <a:srgbClr val="0F172A"/>
+          </a:solidFill>
+          <a:ln>
+            <a:noFill/>
+          </a:ln>
+        </p:spPr>
+        <p:txBody>
+          <a:bodyPr/>
+          <a:lstStyle/>
+          <a:p>
+            <a:endParaRPr/>
+          </a:p>
+        </p:txBody>
+      </p:sp>
+      <p:sp>
+        <p:nvSpPr>
+          <p:cNvPr id="4" name="gold"/>
+          <p:cNvSpPr/>
+          <p:nvPr/>
+        </p:nvSpPr>
+        <p:spPr>
+          <a:xfrm>
+            <a:off x="0" y="1180000"/>
+            <a:ext cx="12192000" cy="50000"/>
+          </a:xfrm>
+          <a:prstGeom prst="roundRect">
+            <a:avLst>
+              <a:gd name="adj" fmla="val 6000"/>
+            </a:avLst>
+          </a:prstGeom>
+          <a:solidFill>
+            <a:srgbClr val="C5A46E"/>
+          </a:solidFill>
+          <a:ln>
+            <a:noFill/>
+          </a:ln>
+        </p:spPr>
+        <p:txBody>
+          <a:bodyPr/>
+          <a:lstStyle/>
+          <a:p>
+            <a:endParaRPr/>
+          </a:p>
+        </p:txBody>
+      </p:sp>
+      <p:sp>
+        <p:nvSpPr>
+          <p:cNvPr id="5" name="t5"/>
+          <p:cNvSpPr txBox="1"/>
+          <p:nvPr/>
+        </p:nvSpPr>
+        <p:spPr>
+          <a:xfrm>
+            <a:off x="420000" y="220000"/>
+            <a:ext cx="11000000" cy="560000"/>
+          </a:xfrm>
+          <a:prstGeom prst="rect">
+            <a:avLst/>
+          </a:prstGeom>
+          <a:noFill/>
+        </p:spPr>
+        <p:txBody>
+          <a:bodyPr wrap="square" anchor="t" lIns="45720" tIns="22860" rIns="45720" bIns="22860"/>
+          <a:lstStyle/>
+          <a:p>
+            <a:pPr algn="l"/>
+            <a:r>
+              <a:rPr lang="en-US" sz="2600" b="1" dirty="0">
+                <a:solidFill>
+                  <a:srgbClr val="FFFFFF"/>
+                </a:solidFill>
+                <a:latin typeface="Calibri" pitchFamily="34" charset="0"/>
+              </a:rPr>
+              <a:t xml:space="preserve">Priority actions / next 90 days</a:t>
+            </a:r>
+          </a:p>
+        </p:txBody>
+      </p:sp>
+      <p:sp>
+        <p:nvSpPr>
+          <p:cNvPr id="6" name="t6"/>
+          <p:cNvSpPr txBox="1"/>
+          <p:nvPr/>
+        </p:nvSpPr>
+        <p:spPr>
+          <a:xfrm>
+            <a:off x="420000" y="740000"/>
+            <a:ext cx="11000000" cy="320000"/>
+          </a:xfrm>
+          <a:prstGeom prst="rect">
+            <a:avLst/>
+          </a:prstGeom>
+          <a:noFill/>
+        </p:spPr>
+        <p:txBody>
+          <a:bodyPr wrap="square" anchor="t" lIns="45720" tIns="22860" rIns="45720" bIns="22860"/>
+          <a:lstStyle/>
+          <a:p>
+            <a:pPr algn="l"/>
+            <a:r>
+              <a:rPr lang="en-US" sz="1200" b="0" dirty="0">
+                <a:solidFill>
+                  <a:srgbClr val="CBD5E1"/>
+                </a:solidFill>
+                <a:latin typeface="Calibri" pitchFamily="34" charset="0"/>
+              </a:rPr>
+              <a:t xml:space="preserve">Taken from the live attention queue. No invented program.</a:t>
+            </a:r>
+          </a:p>
+        </p:txBody>
+      </p:sp>
+      <p:sp>
+        <p:nvSpPr>
+          <p:cNvPr id="20" name="n20"/>
+          <p:cNvSpPr txBox="1"/>
+          <p:nvPr/>
+        </p:nvSpPr>
+        <p:spPr>
+          <a:xfrm>
+            <a:off x="420000" y="1680000"/>
+            <a:ext cx="11300000" cy="610000"/>
+          </a:xfrm>
+          <a:prstGeom prst="rect">
+            <a:avLst/>
+          </a:prstGeom>
+          <a:noFill/>
+        </p:spPr>
+        <p:txBody>
+          <a:bodyPr wrap="square" anchor="t" lIns="45720" tIns="8000" rIns="45720" bIns="8000"/>
+          <a:lstStyle/>
+          <a:p>
+            <a:pPr algn="l"/>
+            <a:r>
+              <a:rPr lang="en-US" sz="1300" b="0" dirty="0">
+                <a:solidFill>
+                  <a:srgbClr val="0F172A"/>
+                </a:solidFill>
+                <a:latin typeface="Calibri" pitchFamily="34" charset="0"/>
+              </a:rPr>
+              <a:t xml:space="preserve">1. Review XFR-00001 — Transfer requiring review. XFR-00001 US-NY → IE is recorded as</a:t>
+            </a:r>
+          </a:p>
+          <a:p>
+            <a:pPr algn="l"/>
+            <a:r>
+              <a:rPr lang="en-US" sz="1300" b="0" dirty="0">
+                <a:solidFill>
+                  <a:srgbClr val="0F172A"/>
+                </a:solidFill>
+                <a:latin typeface="Calibri" pitchFamily="34" charset="0"/>
+              </a:rPr>
+              <a:t xml:space="preserve">review required. This is not a lawfulness finding.</a:t>
+            </a:r>
+          </a:p>
+        </p:txBody>
+      </p:sp>
+      <p:sp>
+        <p:nvSpPr>
+          <p:cNvPr id="21" name="n21"/>
+          <p:cNvSpPr txBox="1"/>
+          <p:nvPr/>
+        </p:nvSpPr>
+        <p:spPr>
+          <a:xfrm>
+            <a:off x="420000" y="2360000"/>
+            <a:ext cx="11300000" cy="610000"/>
+          </a:xfrm>
+          <a:prstGeom prst="rect">
+            <a:avLst/>
+          </a:prstGeom>
+          <a:noFill/>
+        </p:spPr>
+        <p:txBody>
+          <a:bodyPr wrap="square" anchor="t" lIns="45720" tIns="8000" rIns="45720" bIns="8000"/>
+          <a:lstStyle/>
+          <a:p>
+            <a:pPr algn="l"/>
+            <a:r>
+              <a:rPr lang="en-US" sz="1300" b="0" dirty="0">
+                <a:solidFill>
+                  <a:srgbClr val="0F172A"/>
+                </a:solidFill>
+                <a:latin typeface="Calibri" pitchFamily="34" charset="0"/>
+              </a:rPr>
+              <a:t xml:space="preserve">2. Review XFR-00002 — Transfer requiring review. XFR-00002 US-NY → IE is recorded as</a:t>
+            </a:r>
+          </a:p>
+          <a:p>
+            <a:pPr algn="l"/>
+            <a:r>
+              <a:rPr lang="en-US" sz="1300" b="0" dirty="0">
+                <a:solidFill>
+                  <a:srgbClr val="0F172A"/>
+                </a:solidFill>
+                <a:latin typeface="Calibri" pitchFamily="34" charset="0"/>
+              </a:rPr>
+              <a:t xml:space="preserve">review required. This is not a lawfulness finding.</a:t>
+            </a:r>
+          </a:p>
+        </p:txBody>
+      </p:sp>
+      <p:sp>
+        <p:nvSpPr>
+          <p:cNvPr id="22" name="n22"/>
+          <p:cNvSpPr txBox="1"/>
+          <p:nvPr/>
+        </p:nvSpPr>
+        <p:spPr>
+          <a:xfrm>
+            <a:off x="420000" y="3040000"/>
+            <a:ext cx="11300000" cy="610000"/>
+          </a:xfrm>
+          <a:prstGeom prst="rect">
+            <a:avLst/>
+          </a:prstGeom>
+          <a:noFill/>
+        </p:spPr>
+        <p:txBody>
+          <a:bodyPr wrap="square" anchor="t" lIns="45720" tIns="8000" rIns="45720" bIns="8000"/>
+          <a:lstStyle/>
+          <a:p>
+            <a:pPr algn="l"/>
+            <a:r>
+              <a:rPr lang="en-US" sz="1300" b="0" dirty="0">
+                <a:solidFill>
+                  <a:srgbClr val="0F172A"/>
+                </a:solidFill>
+                <a:latin typeface="Calibri" pitchFamily="34" charset="0"/>
+              </a:rPr>
+              <a:t xml:space="preserve">3. Review XFR-00003 — Transfer requiring review. XFR-00003 US-NY → IE is recorded as</a:t>
+            </a:r>
+          </a:p>
+          <a:p>
+            <a:pPr algn="l"/>
+            <a:r>
+              <a:rPr lang="en-US" sz="1300" b="0" dirty="0">
+                <a:solidFill>
+                  <a:srgbClr val="0F172A"/>
+                </a:solidFill>
+                <a:latin typeface="Calibri" pitchFamily="34" charset="0"/>
+              </a:rPr>
+              <a:t xml:space="preserve">review required. This is not a lawfulness finding.</a:t>
+            </a:r>
+          </a:p>
+        </p:txBody>
+      </p:sp>
+      <p:sp>
+        <p:nvSpPr>
+          <p:cNvPr id="23" name="n23"/>
+          <p:cNvSpPr txBox="1"/>
+          <p:nvPr/>
+        </p:nvSpPr>
+        <p:spPr>
+          <a:xfrm>
+            <a:off x="420000" y="3720000"/>
+            <a:ext cx="11300000" cy="610000"/>
+          </a:xfrm>
+          <a:prstGeom prst="rect">
+            <a:avLst/>
+          </a:prstGeom>
+          <a:noFill/>
+        </p:spPr>
+        <p:txBody>
+          <a:bodyPr wrap="square" anchor="t" lIns="45720" tIns="8000" rIns="45720" bIns="8000"/>
+          <a:lstStyle/>
+          <a:p>
+            <a:pPr algn="l"/>
+            <a:r>
+              <a:rPr lang="en-US" sz="1300" b="0" dirty="0">
+                <a:solidFill>
+                  <a:srgbClr val="0F172A"/>
+                </a:solidFill>
+                <a:latin typeface="Calibri" pitchFamily="34" charset="0"/>
+              </a:rPr>
+              <a:t xml:space="preserve">4. Review XFR-00004 — Transfer requiring review. XFR-00004 US-NY → IE is recorded as</a:t>
+            </a:r>
+          </a:p>
+          <a:p>
+            <a:pPr algn="l"/>
+            <a:r>
+              <a:rPr lang="en-US" sz="1300" b="0" dirty="0">
+                <a:solidFill>
+                  <a:srgbClr val="0F172A"/>
+                </a:solidFill>
+                <a:latin typeface="Calibri" pitchFamily="34" charset="0"/>
+              </a:rPr>
+              <a:t xml:space="preserve">review required. This is not a lawfulness finding.</a:t>
+            </a:r>
+          </a:p>
+        </p:txBody>
+      </p:sp>
+      <p:sp>
+        <p:nvSpPr>
+          <p:cNvPr id="24" name="n24"/>
+          <p:cNvSpPr txBox="1"/>
+          <p:nvPr/>
+        </p:nvSpPr>
+        <p:spPr>
+          <a:xfrm>
+            <a:off x="420000" y="4400000"/>
+            <a:ext cx="11300000" cy="610000"/>
+          </a:xfrm>
+          <a:prstGeom prst="rect">
+            <a:avLst/>
+          </a:prstGeom>
+          <a:noFill/>
+        </p:spPr>
+        <p:txBody>
+          <a:bodyPr wrap="square" anchor="t" lIns="45720" tIns="8000" rIns="45720" bIns="8000"/>
+          <a:lstStyle/>
+          <a:p>
+            <a:pPr algn="l"/>
+            <a:r>
+              <a:rPr lang="en-US" sz="1300" b="0" dirty="0">
+                <a:solidFill>
+                  <a:srgbClr val="0F172A"/>
+                </a:solidFill>
+                <a:latin typeface="Calibri" pitchFamily="34" charset="0"/>
+              </a:rPr>
+              <a:t xml:space="preserve">5. Review GAP-00001 — Open privacy-related gap. GAP-00001 500.07 is mapped to controls</a:t>
+            </a:r>
+          </a:p>
+          <a:p>
+            <a:pPr algn="l"/>
+            <a:r>
+              <a:rPr lang="en-US" sz="1300" b="0" dirty="0">
+                <a:solidFill>
+                  <a:srgbClr val="0F172A"/>
+                </a:solidFill>
+                <a:latin typeface="Calibri" pitchFamily="34" charset="0"/>
+              </a:rPr>
+              <a:t xml:space="preserve">that are not implemented. A gap is remaining work, not a legal conclusion.</a:t>
+            </a:r>
+          </a:p>
+        </p:txBody>
+      </p:sp>
+      <p:sp>
+        <p:nvSpPr>
+          <p:cNvPr id="900" name="ft"/>
+          <p:cNvSpPr/>
+          <p:nvPr/>
+        </p:nvSpPr>
+        <p:spPr>
+          <a:xfrm>
+            <a:off x="0" y="6520000"/>
+            <a:ext cx="12192000" cy="340000"/>
+          </a:xfrm>
+          <a:prstGeom prst="roundRect">
+            <a:avLst>
+              <a:gd name="adj" fmla="val 6000"/>
+            </a:avLst>
+          </a:prstGeom>
+          <a:solidFill>
+            <a:srgbClr val="F1F5F9"/>
+          </a:solidFill>
+          <a:ln>
+            <a:noFill/>
+          </a:ln>
+        </p:spPr>
+        <p:txBody>
+          <a:bodyPr/>
+          <a:lstStyle/>
+          <a:p>
+            <a:endParaRPr/>
+          </a:p>
+        </p:txBody>
+      </p:sp>
+      <p:sp>
+        <p:nvSpPr>
+          <p:cNvPr id="901" name="t901"/>
+          <p:cNvSpPr txBox="1"/>
+          <p:nvPr/>
+        </p:nvSpPr>
+        <p:spPr>
+          <a:xfrm>
+            <a:off x="360000" y="6560000"/>
+            <a:ext cx="7800000" cy="260000"/>
+          </a:xfrm>
+          <a:prstGeom prst="rect">
+            <a:avLst/>
+          </a:prstGeom>
+          <a:noFill/>
+        </p:spPr>
+        <p:txBody>
+          <a:bodyPr wrap="square" anchor="t" lIns="45720" tIns="22860" rIns="45720" bIns="22860"/>
+          <a:lstStyle/>
+          <a:p>
+            <a:pPr algn="l"/>
+            <a:r>
+              <a:rPr lang="en-US" sz="900" b="0" dirty="0">
+                <a:solidFill>
+                  <a:srgbClr val="64748B"/>
+                </a:solidFill>
+                <a:latin typeface="Calibri" pitchFamily="34" charset="0"/>
+              </a:rPr>
+              <a:t xml:space="preserve">Supreme Privacy Board Report · Confidential · Not legal advice</a:t>
+            </a:r>
+          </a:p>
+        </p:txBody>
+      </p:sp>
+      <p:sp>
+        <p:nvSpPr>
+          <p:cNvPr id="902" name="t902"/>
+          <p:cNvSpPr txBox="1"/>
+          <p:nvPr/>
+        </p:nvSpPr>
+        <p:spPr>
+          <a:xfrm>
+            <a:off x="10400000" y="6560000"/>
+            <a:ext cx="1400000" cy="260000"/>
+          </a:xfrm>
+          <a:prstGeom prst="rect">
+            <a:avLst/>
+          </a:prstGeom>
+          <a:noFill/>
+        </p:spPr>
+        <p:txBody>
+          <a:bodyPr wrap="square" anchor="t" lIns="45720" tIns="22860" rIns="45720" bIns="22860"/>
+          <a:lstStyle/>
+          <a:p>
+            <a:pPr algn="r"/>
+            <a:r>
+              <a:rPr lang="en-US" sz="900" b="0" dirty="0">
+                <a:solidFill>
+                  <a:srgbClr val="64748B"/>
+                </a:solidFill>
+                <a:latin typeface="Calibri" pitchFamily="34" charset="0"/>
+              </a:rPr>
+              <a:t xml:space="preserve">13 / 14</a:t>
+            </a:r>
+          </a:p>
+        </p:txBody>
+      </p:sp>
+    </p:spTree>
+  </p:cSld>
+  <p:clrMapOvr>
+    <a:masterClrMapping/>
+  </p:clrMapOvr>
+</p:sld>
+</file>
+
+<file path=ppt/slides/slide14.xml><?xml version="1.0" encoding="utf-8"?>
+<p:sld xmlns:a="http://schemas.openxmlformats.org/drawingml/2006/main" xmlns:r="http://schemas.openxmlformats.org/officeDocument/2006/relationships" xmlns:p="http://schemas.openxmlformats.org/presentationml/2006/main">
+  <p:cSld>
+    <p:spTree>
+      <p:nvGrpSpPr>
+        <p:cNvPr id="1" name=""/>
+        <p:cNvGrpSpPr/>
+        <p:nvPr/>
+      </p:nvGrpSpPr>
+      <p:grpSpPr>
+        <a:xfrm>
+          <a:off x="0" y="0"/>
+          <a:ext cx="0" cy="0"/>
+          <a:chOff x="0" y="0"/>
+          <a:chExt cx="0" cy="0"/>
+        </a:xfrm>
+      </p:grpSpPr>
+      <p:sp>
+        <p:nvSpPr>
+          <p:cNvPr id="3" name="bar"/>
+          <p:cNvSpPr/>
+          <p:nvPr/>
+        </p:nvSpPr>
+        <p:spPr>
+          <a:xfrm>
+            <a:off x="0" y="0"/>
+            <a:ext cx="12192000" cy="1180000"/>
+          </a:xfrm>
+          <a:prstGeom prst="roundRect">
+            <a:avLst>
+              <a:gd name="adj" fmla="val 6000"/>
+            </a:avLst>
+          </a:prstGeom>
+          <a:solidFill>
+            <a:srgbClr val="0F172A"/>
+          </a:solidFill>
+          <a:ln>
+            <a:noFill/>
+          </a:ln>
+        </p:spPr>
+        <p:txBody>
+          <a:bodyPr/>
+          <a:lstStyle/>
+          <a:p>
+            <a:endParaRPr/>
+          </a:p>
+        </p:txBody>
+      </p:sp>
+      <p:sp>
+        <p:nvSpPr>
+          <p:cNvPr id="4" name="gold"/>
+          <p:cNvSpPr/>
+          <p:nvPr/>
+        </p:nvSpPr>
+        <p:spPr>
+          <a:xfrm>
+            <a:off x="0" y="1180000"/>
+            <a:ext cx="12192000" cy="50000"/>
+          </a:xfrm>
+          <a:prstGeom prst="roundRect">
+            <a:avLst>
+              <a:gd name="adj" fmla="val 6000"/>
+            </a:avLst>
+          </a:prstGeom>
+          <a:solidFill>
+            <a:srgbClr val="C5A46E"/>
+          </a:solidFill>
+          <a:ln>
+            <a:noFill/>
+          </a:ln>
+        </p:spPr>
+        <p:txBody>
+          <a:bodyPr/>
+          <a:lstStyle/>
+          <a:p>
+            <a:endParaRPr/>
+          </a:p>
+        </p:txBody>
+      </p:sp>
+      <p:sp>
+        <p:nvSpPr>
+          <p:cNvPr id="5" name="t5"/>
+          <p:cNvSpPr txBox="1"/>
+          <p:nvPr/>
+        </p:nvSpPr>
+        <p:spPr>
+          <a:xfrm>
+            <a:off x="420000" y="220000"/>
+            <a:ext cx="11000000" cy="560000"/>
+          </a:xfrm>
+          <a:prstGeom prst="rect">
+            <a:avLst/>
+          </a:prstGeom>
+          <a:noFill/>
+        </p:spPr>
+        <p:txBody>
+          <a:bodyPr wrap="square" anchor="t" lIns="45720" tIns="22860" rIns="45720" bIns="22860"/>
+          <a:lstStyle/>
+          <a:p>
+            <a:pPr algn="l"/>
+            <a:r>
+              <a:rPr lang="en-US" sz="2600" b="1" dirty="0">
+                <a:solidFill>
+                  <a:srgbClr val="FFFFFF"/>
+                </a:solidFill>
+                <a:latin typeface="Calibri" pitchFamily="34" charset="0"/>
+              </a:rPr>
+              <a:t xml:space="preserve">Priority actions / next 90 days · continued</a:t>
+            </a:r>
+          </a:p>
+        </p:txBody>
+      </p:sp>
+      <p:sp>
+        <p:nvSpPr>
+          <p:cNvPr id="6" name="t6"/>
+          <p:cNvSpPr txBox="1"/>
+          <p:nvPr/>
+        </p:nvSpPr>
+        <p:spPr>
+          <a:xfrm>
+            <a:off x="420000" y="740000"/>
+            <a:ext cx="11000000" cy="320000"/>
+          </a:xfrm>
+          <a:prstGeom prst="rect">
+            <a:avLst/>
+          </a:prstGeom>
+          <a:noFill/>
+        </p:spPr>
+        <p:txBody>
+          <a:bodyPr wrap="square" anchor="t" lIns="45720" tIns="22860" rIns="45720" bIns="22860"/>
+          <a:lstStyle/>
+          <a:p>
+            <a:pPr algn="l"/>
+            <a:r>
+              <a:rPr lang="en-US" sz="1200" b="0" dirty="0">
+                <a:solidFill>
+                  <a:srgbClr val="CBD5E1"/>
+                </a:solidFill>
+                <a:latin typeface="Calibri" pitchFamily="34" charset="0"/>
+              </a:rPr>
+              <a:t xml:space="preserve">Taken from the live attention queue. No invented program.</a:t>
+            </a:r>
+          </a:p>
+        </p:txBody>
+      </p:sp>
+      <p:sp>
+        <p:nvSpPr>
+          <p:cNvPr id="20" name="n20"/>
+          <p:cNvSpPr txBox="1"/>
+          <p:nvPr/>
+        </p:nvSpPr>
+        <p:spPr>
+          <a:xfrm>
+            <a:off x="420000" y="1680000"/>
+            <a:ext cx="11300000" cy="610000"/>
+          </a:xfrm>
+          <a:prstGeom prst="rect">
+            <a:avLst/>
+          </a:prstGeom>
+          <a:noFill/>
+        </p:spPr>
+        <p:txBody>
+          <a:bodyPr wrap="square" anchor="t" lIns="45720" tIns="8000" rIns="45720" bIns="8000"/>
+          <a:lstStyle/>
+          <a:p>
+            <a:pPr algn="l"/>
+            <a:r>
+              <a:rPr lang="en-US" sz="1300" b="0" dirty="0">
+                <a:solidFill>
+                  <a:srgbClr val="0F172A"/>
+                </a:solidFill>
+                <a:latin typeface="Calibri" pitchFamily="34" charset="0"/>
+              </a:rPr>
+              <a:t xml:space="preserve">6. Review GAP-00003 — Open privacy-related gap. GAP-00003 A.15 is mapped to controls</a:t>
+            </a:r>
+          </a:p>
+          <a:p>
+            <a:pPr algn="l"/>
+            <a:r>
+              <a:rPr lang="en-US" sz="1300" b="0" dirty="0">
+                <a:solidFill>
+                  <a:srgbClr val="0F172A"/>
+                </a:solidFill>
+                <a:latin typeface="Calibri" pitchFamily="34" charset="0"/>
+              </a:rPr>
+              <a:t xml:space="preserve">that are not implemented. A gap is remaining work, not a legal conclusion.</a:t>
+            </a:r>
+          </a:p>
+        </p:txBody>
+      </p:sp>
+      <p:sp>
+        <p:nvSpPr>
+          <p:cNvPr id="21" name="n21"/>
+          <p:cNvSpPr txBox="1"/>
+          <p:nvPr/>
+        </p:nvSpPr>
+        <p:spPr>
+          <a:xfrm>
+            <a:off x="420000" y="2360000"/>
+            <a:ext cx="11300000" cy="610000"/>
+          </a:xfrm>
+          <a:prstGeom prst="rect">
+            <a:avLst/>
+          </a:prstGeom>
+          <a:noFill/>
+        </p:spPr>
+        <p:txBody>
+          <a:bodyPr wrap="square" anchor="t" lIns="45720" tIns="8000" rIns="45720" bIns="8000"/>
+          <a:lstStyle/>
+          <a:p>
+            <a:pPr algn="l"/>
+            <a:r>
+              <a:rPr lang="en-US" sz="1300" b="0" dirty="0">
+                <a:solidFill>
+                  <a:srgbClr val="0F172A"/>
+                </a:solidFill>
+                <a:latin typeface="Calibri" pitchFamily="34" charset="0"/>
+              </a:rPr>
+              <a:t xml:space="preserve">7. Review GAP-00002 — Open privacy-related gap. GAP-00002 500.07 has no current CLEAN</a:t>
+            </a:r>
+          </a:p>
+          <a:p>
+            <a:pPr algn="l"/>
+            <a:r>
+              <a:rPr lang="en-US" sz="1300" b="0" dirty="0">
+                <a:solidFill>
+                  <a:srgbClr val="0F172A"/>
+                </a:solidFill>
+                <a:latin typeface="Calibri" pitchFamily="34" charset="0"/>
+              </a:rPr>
+              <a:t xml:space="preserve">evidence. A gap is remaining work, not a legal conclusion.</a:t>
+            </a:r>
+          </a:p>
+        </p:txBody>
+      </p:sp>
+      <p:sp>
+        <p:nvSpPr>
+          <p:cNvPr id="22" name="n22"/>
+          <p:cNvSpPr txBox="1"/>
+          <p:nvPr/>
+        </p:nvSpPr>
+        <p:spPr>
+          <a:xfrm>
+            <a:off x="420000" y="3040000"/>
+            <a:ext cx="11300000" cy="610000"/>
+          </a:xfrm>
+          <a:prstGeom prst="rect">
+            <a:avLst/>
+          </a:prstGeom>
+          <a:noFill/>
+        </p:spPr>
+        <p:txBody>
+          <a:bodyPr wrap="square" anchor="t" lIns="45720" tIns="8000" rIns="45720" bIns="8000"/>
+          <a:lstStyle/>
+          <a:p>
+            <a:pPr algn="l"/>
+            <a:r>
+              <a:rPr lang="en-US" sz="1300" b="0" dirty="0">
+                <a:solidFill>
+                  <a:srgbClr val="0F172A"/>
+                </a:solidFill>
+                <a:latin typeface="Calibri" pitchFamily="34" charset="0"/>
+              </a:rPr>
+              <a:t xml:space="preserve">8. Review GAP-00004 — Open privacy-related gap. GAP-00004 A.15 has no current CLEAN</a:t>
+            </a:r>
+          </a:p>
+          <a:p>
+            <a:pPr algn="l"/>
+            <a:r>
+              <a:rPr lang="en-US" sz="1300" b="0" dirty="0">
+                <a:solidFill>
+                  <a:srgbClr val="0F172A"/>
+                </a:solidFill>
+                <a:latin typeface="Calibri" pitchFamily="34" charset="0"/>
+              </a:rPr>
+              <a:t xml:space="preserve">evidence. A gap is remaining work, not a legal conclusion.</a:t>
+            </a:r>
+          </a:p>
+        </p:txBody>
+      </p:sp>
+      <p:sp>
+        <p:nvSpPr>
+          <p:cNvPr id="80" name="t80"/>
+          <p:cNvSpPr txBox="1"/>
+          <p:nvPr/>
+        </p:nvSpPr>
+        <p:spPr>
+          <a:xfrm>
+            <a:off x="420000" y="5600000"/>
+            <a:ext cx="11000000" cy="360000"/>
+          </a:xfrm>
+          <a:prstGeom prst="rect">
+            <a:avLst/>
+          </a:prstGeom>
+          <a:noFill/>
+        </p:spPr>
+        <p:txBody>
+          <a:bodyPr wrap="square" anchor="t" lIns="45720" tIns="22860" rIns="45720" bIns="22860"/>
+          <a:lstStyle/>
+          <a:p>
+            <a:pPr algn="l"/>
+            <a:r>
+              <a:rPr lang="en-US" sz="1200" b="0" dirty="0">
+                <a:solidFill>
+                  <a:srgbClr val="64748B"/>
+                </a:solidFill>
+                <a:latin typeface="Calibri" pitchFamily="34" charset="0"/>
+              </a:rPr>
+              <a:t xml:space="preserve">Consent collector remains not configured / manual. No trend available.</a:t>
+            </a:r>
+          </a:p>
+        </p:txBody>
+      </p:sp>
+      <p:sp>
+        <p:nvSpPr>
+          <p:cNvPr id="900" name="ft"/>
+          <p:cNvSpPr/>
+          <p:nvPr/>
+        </p:nvSpPr>
+        <p:spPr>
+          <a:xfrm>
+            <a:off x="0" y="6520000"/>
+            <a:ext cx="12192000" cy="340000"/>
+          </a:xfrm>
+          <a:prstGeom prst="roundRect">
+            <a:avLst>
+              <a:gd name="adj" fmla="val 6000"/>
+            </a:avLst>
+          </a:prstGeom>
+          <a:solidFill>
+            <a:srgbClr val="F1F5F9"/>
+          </a:solidFill>
+          <a:ln>
+            <a:noFill/>
+          </a:ln>
+        </p:spPr>
+        <p:txBody>
+          <a:bodyPr/>
+          <a:lstStyle/>
+          <a:p>
+            <a:endParaRPr/>
+          </a:p>
+        </p:txBody>
+      </p:sp>
+      <p:sp>
+        <p:nvSpPr>
+          <p:cNvPr id="901" name="t901"/>
+          <p:cNvSpPr txBox="1"/>
+          <p:nvPr/>
+        </p:nvSpPr>
+        <p:spPr>
+          <a:xfrm>
+            <a:off x="360000" y="6560000"/>
+            <a:ext cx="7800000" cy="260000"/>
+          </a:xfrm>
+          <a:prstGeom prst="rect">
+            <a:avLst/>
+          </a:prstGeom>
+          <a:noFill/>
+        </p:spPr>
+        <p:txBody>
+          <a:bodyPr wrap="square" anchor="t" lIns="45720" tIns="22860" rIns="45720" bIns="22860"/>
+          <a:lstStyle/>
+          <a:p>
+            <a:pPr algn="l"/>
+            <a:r>
+              <a:rPr lang="en-US" sz="900" b="0" dirty="0">
+                <a:solidFill>
+                  <a:srgbClr val="64748B"/>
+                </a:solidFill>
+                <a:latin typeface="Calibri" pitchFamily="34" charset="0"/>
+              </a:rPr>
+              <a:t xml:space="preserve">Supreme Privacy Board Report · Confidential · Not legal advice</a:t>
+            </a:r>
+          </a:p>
+        </p:txBody>
+      </p:sp>
+      <p:sp>
+        <p:nvSpPr>
+          <p:cNvPr id="902" name="t902"/>
+          <p:cNvSpPr txBox="1"/>
+          <p:nvPr/>
+        </p:nvSpPr>
+        <p:spPr>
+          <a:xfrm>
+            <a:off x="10400000" y="6560000"/>
+            <a:ext cx="1400000" cy="260000"/>
+          </a:xfrm>
+          <a:prstGeom prst="rect">
+            <a:avLst/>
+          </a:prstGeom>
+          <a:noFill/>
+        </p:spPr>
+        <p:txBody>
+          <a:bodyPr wrap="square" anchor="t" lIns="45720" tIns="22860" rIns="45720" bIns="22860"/>
+          <a:lstStyle/>
+          <a:p>
+            <a:pPr algn="r"/>
+            <a:r>
+              <a:rPr lang="en-US" sz="900" b="0" dirty="0">
+                <a:solidFill>
+                  <a:srgbClr val="64748B"/>
+                </a:solidFill>
+                <a:latin typeface="Calibri" pitchFamily="34" charset="0"/>
+              </a:rPr>
+              <a:t xml:space="preserve">14 / 14</a:t>
             </a:r>
           </a:p>
         </p:txBody>
@@ -3088,7 +4028,7 @@
                 </a:solidFill>
                 <a:latin typeface="Calibri" pitchFamily="34" charset="0"/>
               </a:rPr>
-              <a:t xml:space="preserve">2 / 12</a:t>
+              <a:t xml:space="preserve">2 / 14</a:t>
             </a:r>
           </a:p>
         </p:txBody>
@@ -3644,22 +4584,22 @@
       </p:sp>
       <p:sp>
         <p:nvSpPr>
-          <p:cNvPr id="60" name="t60"/>
+          <p:cNvPr id="60" name="n60"/>
           <p:cNvSpPr txBox="1"/>
           <p:nvPr/>
         </p:nvSpPr>
         <p:spPr>
           <a:xfrm>
             <a:off x="420000" y="3200000"/>
-            <a:ext cx="11300000" cy="420000"/>
-          </a:xfrm>
-          <a:prstGeom prst="rect">
-            <a:avLst/>
-          </a:prstGeom>
-          <a:noFill/>
-        </p:spPr>
-        <p:txBody>
-          <a:bodyPr wrap="square" anchor="t" lIns="45720" tIns="22860" rIns="45720" bIns="22860"/>
+            <a:ext cx="11300000" cy="330000"/>
+          </a:xfrm>
+          <a:prstGeom prst="rect">
+            <a:avLst/>
+          </a:prstGeom>
+          <a:noFill/>
+        </p:spPr>
+        <p:txBody>
+          <a:bodyPr wrap="square" anchor="t" lIns="45720" tIns="8000" rIns="45720" bIns="8000"/>
           <a:lstStyle/>
           <a:p>
             <a:pPr algn="l"/>
@@ -3677,22 +4617,22 @@
       </p:sp>
       <p:sp>
         <p:nvSpPr>
-          <p:cNvPr id="61" name="t61"/>
-          <p:cNvSpPr txBox="1"/>
-          <p:nvPr/>
-        </p:nvSpPr>
-        <p:spPr>
-          <a:xfrm>
-            <a:off x="420000" y="3660000"/>
-            <a:ext cx="11300000" cy="420000"/>
-          </a:xfrm>
-          <a:prstGeom prst="rect">
-            <a:avLst/>
-          </a:prstGeom>
-          <a:noFill/>
-        </p:spPr>
-        <p:txBody>
-          <a:bodyPr wrap="square" anchor="t" lIns="45720" tIns="22860" rIns="45720" bIns="22860"/>
+          <p:cNvPr id="61" name="n61"/>
+          <p:cNvSpPr txBox="1"/>
+          <p:nvPr/>
+        </p:nvSpPr>
+        <p:spPr>
+          <a:xfrm>
+            <a:off x="420000" y="3590000"/>
+            <a:ext cx="11300000" cy="330000"/>
+          </a:xfrm>
+          <a:prstGeom prst="rect">
+            <a:avLst/>
+          </a:prstGeom>
+          <a:noFill/>
+        </p:spPr>
+        <p:txBody>
+          <a:bodyPr wrap="square" anchor="t" lIns="45720" tIns="8000" rIns="45720" bIns="8000"/>
           <a:lstStyle/>
           <a:p>
             <a:pPr algn="l"/>
@@ -3710,22 +4650,22 @@
       </p:sp>
       <p:sp>
         <p:nvSpPr>
-          <p:cNvPr id="62" name="t62"/>
-          <p:cNvSpPr txBox="1"/>
-          <p:nvPr/>
-        </p:nvSpPr>
-        <p:spPr>
-          <a:xfrm>
-            <a:off x="420000" y="4120000"/>
-            <a:ext cx="11300000" cy="420000"/>
-          </a:xfrm>
-          <a:prstGeom prst="rect">
-            <a:avLst/>
-          </a:prstGeom>
-          <a:noFill/>
-        </p:spPr>
-        <p:txBody>
-          <a:bodyPr wrap="square" anchor="t" lIns="45720" tIns="22860" rIns="45720" bIns="22860"/>
+          <p:cNvPr id="62" name="n62"/>
+          <p:cNvSpPr txBox="1"/>
+          <p:nvPr/>
+        </p:nvSpPr>
+        <p:spPr>
+          <a:xfrm>
+            <a:off x="420000" y="3980000"/>
+            <a:ext cx="11300000" cy="330000"/>
+          </a:xfrm>
+          <a:prstGeom prst="rect">
+            <a:avLst/>
+          </a:prstGeom>
+          <a:noFill/>
+        </p:spPr>
+        <p:txBody>
+          <a:bodyPr wrap="square" anchor="t" lIns="45720" tIns="8000" rIns="45720" bIns="8000"/>
           <a:lstStyle/>
           <a:p>
             <a:pPr algn="l"/>
@@ -3743,22 +4683,22 @@
       </p:sp>
       <p:sp>
         <p:nvSpPr>
-          <p:cNvPr id="63" name="t63"/>
-          <p:cNvSpPr txBox="1"/>
-          <p:nvPr/>
-        </p:nvSpPr>
-        <p:spPr>
-          <a:xfrm>
-            <a:off x="420000" y="4580000"/>
-            <a:ext cx="11300000" cy="420000"/>
-          </a:xfrm>
-          <a:prstGeom prst="rect">
-            <a:avLst/>
-          </a:prstGeom>
-          <a:noFill/>
-        </p:spPr>
-        <p:txBody>
-          <a:bodyPr wrap="square" anchor="t" lIns="45720" tIns="22860" rIns="45720" bIns="22860"/>
+          <p:cNvPr id="63" name="n63"/>
+          <p:cNvSpPr txBox="1"/>
+          <p:nvPr/>
+        </p:nvSpPr>
+        <p:spPr>
+          <a:xfrm>
+            <a:off x="420000" y="4370000"/>
+            <a:ext cx="11300000" cy="330000"/>
+          </a:xfrm>
+          <a:prstGeom prst="rect">
+            <a:avLst/>
+          </a:prstGeom>
+          <a:noFill/>
+        </p:spPr>
+        <p:txBody>
+          <a:bodyPr wrap="square" anchor="t" lIns="45720" tIns="8000" rIns="45720" bIns="8000"/>
           <a:lstStyle/>
           <a:p>
             <a:pPr algn="l"/>
@@ -3866,7 +4806,7 @@
                 </a:solidFill>
                 <a:latin typeface="Calibri" pitchFamily="34" charset="0"/>
               </a:rPr>
-              <a:t xml:space="preserve">3 / 12</a:t>
+              <a:t xml:space="preserve">3 / 14</a:t>
             </a:r>
           </a:p>
         </p:txBody>
@@ -4422,22 +5362,22 @@
       </p:sp>
       <p:sp>
         <p:nvSpPr>
-          <p:cNvPr id="60" name="t60"/>
+          <p:cNvPr id="60" name="n60"/>
           <p:cNvSpPr txBox="1"/>
           <p:nvPr/>
         </p:nvSpPr>
         <p:spPr>
           <a:xfrm>
             <a:off x="420000" y="3200000"/>
-            <a:ext cx="11300000" cy="420000"/>
-          </a:xfrm>
-          <a:prstGeom prst="rect">
-            <a:avLst/>
-          </a:prstGeom>
-          <a:noFill/>
-        </p:spPr>
-        <p:txBody>
-          <a:bodyPr wrap="square" anchor="t" lIns="45720" tIns="22860" rIns="45720" bIns="22860"/>
+            <a:ext cx="11300000" cy="330000"/>
+          </a:xfrm>
+          <a:prstGeom prst="rect">
+            <a:avLst/>
+          </a:prstGeom>
+          <a:noFill/>
+        </p:spPr>
+        <p:txBody>
+          <a:bodyPr wrap="square" anchor="t" lIns="45720" tIns="8000" rIns="45720" bIns="8000"/>
           <a:lstStyle/>
           <a:p>
             <a:pPr algn="l"/>
@@ -4455,22 +5395,22 @@
       </p:sp>
       <p:sp>
         <p:nvSpPr>
-          <p:cNvPr id="61" name="t61"/>
-          <p:cNvSpPr txBox="1"/>
-          <p:nvPr/>
-        </p:nvSpPr>
-        <p:spPr>
-          <a:xfrm>
-            <a:off x="420000" y="3660000"/>
-            <a:ext cx="11300000" cy="420000"/>
-          </a:xfrm>
-          <a:prstGeom prst="rect">
-            <a:avLst/>
-          </a:prstGeom>
-          <a:noFill/>
-        </p:spPr>
-        <p:txBody>
-          <a:bodyPr wrap="square" anchor="t" lIns="45720" tIns="22860" rIns="45720" bIns="22860"/>
+          <p:cNvPr id="61" name="n61"/>
+          <p:cNvSpPr txBox="1"/>
+          <p:nvPr/>
+        </p:nvSpPr>
+        <p:spPr>
+          <a:xfrm>
+            <a:off x="420000" y="3590000"/>
+            <a:ext cx="11300000" cy="330000"/>
+          </a:xfrm>
+          <a:prstGeom prst="rect">
+            <a:avLst/>
+          </a:prstGeom>
+          <a:noFill/>
+        </p:spPr>
+        <p:txBody>
+          <a:bodyPr wrap="square" anchor="t" lIns="45720" tIns="8000" rIns="45720" bIns="8000"/>
           <a:lstStyle/>
           <a:p>
             <a:pPr algn="l"/>
@@ -4488,22 +5428,22 @@
       </p:sp>
       <p:sp>
         <p:nvSpPr>
-          <p:cNvPr id="62" name="t62"/>
-          <p:cNvSpPr txBox="1"/>
-          <p:nvPr/>
-        </p:nvSpPr>
-        <p:spPr>
-          <a:xfrm>
-            <a:off x="420000" y="4120000"/>
-            <a:ext cx="11300000" cy="420000"/>
-          </a:xfrm>
-          <a:prstGeom prst="rect">
-            <a:avLst/>
-          </a:prstGeom>
-          <a:noFill/>
-        </p:spPr>
-        <p:txBody>
-          <a:bodyPr wrap="square" anchor="t" lIns="45720" tIns="22860" rIns="45720" bIns="22860"/>
+          <p:cNvPr id="62" name="n62"/>
+          <p:cNvSpPr txBox="1"/>
+          <p:nvPr/>
+        </p:nvSpPr>
+        <p:spPr>
+          <a:xfrm>
+            <a:off x="420000" y="3980000"/>
+            <a:ext cx="11300000" cy="330000"/>
+          </a:xfrm>
+          <a:prstGeom prst="rect">
+            <a:avLst/>
+          </a:prstGeom>
+          <a:noFill/>
+        </p:spPr>
+        <p:txBody>
+          <a:bodyPr wrap="square" anchor="t" lIns="45720" tIns="8000" rIns="45720" bIns="8000"/>
           <a:lstStyle/>
           <a:p>
             <a:pPr algn="l"/>
@@ -4521,22 +5461,22 @@
       </p:sp>
       <p:sp>
         <p:nvSpPr>
-          <p:cNvPr id="63" name="t63"/>
-          <p:cNvSpPr txBox="1"/>
-          <p:nvPr/>
-        </p:nvSpPr>
-        <p:spPr>
-          <a:xfrm>
-            <a:off x="420000" y="4580000"/>
-            <a:ext cx="11300000" cy="420000"/>
-          </a:xfrm>
-          <a:prstGeom prst="rect">
-            <a:avLst/>
-          </a:prstGeom>
-          <a:noFill/>
-        </p:spPr>
-        <p:txBody>
-          <a:bodyPr wrap="square" anchor="t" lIns="45720" tIns="22860" rIns="45720" bIns="22860"/>
+          <p:cNvPr id="63" name="n63"/>
+          <p:cNvSpPr txBox="1"/>
+          <p:nvPr/>
+        </p:nvSpPr>
+        <p:spPr>
+          <a:xfrm>
+            <a:off x="420000" y="4370000"/>
+            <a:ext cx="11300000" cy="330000"/>
+          </a:xfrm>
+          <a:prstGeom prst="rect">
+            <a:avLst/>
+          </a:prstGeom>
+          <a:noFill/>
+        </p:spPr>
+        <p:txBody>
+          <a:bodyPr wrap="square" anchor="t" lIns="45720" tIns="8000" rIns="45720" bIns="8000"/>
           <a:lstStyle/>
           <a:p>
             <a:pPr algn="l"/>
@@ -4677,7 +5617,7 @@
                 </a:solidFill>
                 <a:latin typeface="Calibri" pitchFamily="34" charset="0"/>
               </a:rPr>
-              <a:t xml:space="preserve">4 / 12</a:t>
+              <a:t xml:space="preserve">4 / 14</a:t>
             </a:r>
           </a:p>
         </p:txBody>
@@ -5233,22 +6173,22 @@
       </p:sp>
       <p:sp>
         <p:nvSpPr>
-          <p:cNvPr id="60" name="t60"/>
+          <p:cNvPr id="60" name="n60"/>
           <p:cNvSpPr txBox="1"/>
           <p:nvPr/>
         </p:nvSpPr>
         <p:spPr>
           <a:xfrm>
             <a:off x="420000" y="3200000"/>
-            <a:ext cx="11300000" cy="420000"/>
-          </a:xfrm>
-          <a:prstGeom prst="rect">
-            <a:avLst/>
-          </a:prstGeom>
-          <a:noFill/>
-        </p:spPr>
-        <p:txBody>
-          <a:bodyPr wrap="square" anchor="t" lIns="45720" tIns="22860" rIns="45720" bIns="22860"/>
+            <a:ext cx="11300000" cy="330000"/>
+          </a:xfrm>
+          <a:prstGeom prst="rect">
+            <a:avLst/>
+          </a:prstGeom>
+          <a:noFill/>
+        </p:spPr>
+        <p:txBody>
+          <a:bodyPr wrap="square" anchor="t" lIns="45720" tIns="8000" rIns="45720" bIns="8000"/>
           <a:lstStyle/>
           <a:p>
             <a:pPr algn="l"/>
@@ -5266,22 +6206,22 @@
       </p:sp>
       <p:sp>
         <p:nvSpPr>
-          <p:cNvPr id="61" name="t61"/>
-          <p:cNvSpPr txBox="1"/>
-          <p:nvPr/>
-        </p:nvSpPr>
-        <p:spPr>
-          <a:xfrm>
-            <a:off x="420000" y="3660000"/>
-            <a:ext cx="11300000" cy="420000"/>
-          </a:xfrm>
-          <a:prstGeom prst="rect">
-            <a:avLst/>
-          </a:prstGeom>
-          <a:noFill/>
-        </p:spPr>
-        <p:txBody>
-          <a:bodyPr wrap="square" anchor="t" lIns="45720" tIns="22860" rIns="45720" bIns="22860"/>
+          <p:cNvPr id="61" name="n61"/>
+          <p:cNvSpPr txBox="1"/>
+          <p:nvPr/>
+        </p:nvSpPr>
+        <p:spPr>
+          <a:xfrm>
+            <a:off x="420000" y="3590000"/>
+            <a:ext cx="11300000" cy="330000"/>
+          </a:xfrm>
+          <a:prstGeom prst="rect">
+            <a:avLst/>
+          </a:prstGeom>
+          <a:noFill/>
+        </p:spPr>
+        <p:txBody>
+          <a:bodyPr wrap="square" anchor="t" lIns="45720" tIns="8000" rIns="45720" bIns="8000"/>
           <a:lstStyle/>
           <a:p>
             <a:pPr algn="l"/>
@@ -5299,22 +6239,22 @@
       </p:sp>
       <p:sp>
         <p:nvSpPr>
-          <p:cNvPr id="62" name="t62"/>
-          <p:cNvSpPr txBox="1"/>
-          <p:nvPr/>
-        </p:nvSpPr>
-        <p:spPr>
-          <a:xfrm>
-            <a:off x="420000" y="4120000"/>
-            <a:ext cx="11300000" cy="420000"/>
-          </a:xfrm>
-          <a:prstGeom prst="rect">
-            <a:avLst/>
-          </a:prstGeom>
-          <a:noFill/>
-        </p:spPr>
-        <p:txBody>
-          <a:bodyPr wrap="square" anchor="t" lIns="45720" tIns="22860" rIns="45720" bIns="22860"/>
+          <p:cNvPr id="62" name="n62"/>
+          <p:cNvSpPr txBox="1"/>
+          <p:nvPr/>
+        </p:nvSpPr>
+        <p:spPr>
+          <a:xfrm>
+            <a:off x="420000" y="3980000"/>
+            <a:ext cx="11300000" cy="330000"/>
+          </a:xfrm>
+          <a:prstGeom prst="rect">
+            <a:avLst/>
+          </a:prstGeom>
+          <a:noFill/>
+        </p:spPr>
+        <p:txBody>
+          <a:bodyPr wrap="square" anchor="t" lIns="45720" tIns="8000" rIns="45720" bIns="8000"/>
           <a:lstStyle/>
           <a:p>
             <a:pPr algn="l"/>
@@ -5332,22 +6272,22 @@
       </p:sp>
       <p:sp>
         <p:nvSpPr>
-          <p:cNvPr id="63" name="t63"/>
-          <p:cNvSpPr txBox="1"/>
-          <p:nvPr/>
-        </p:nvSpPr>
-        <p:spPr>
-          <a:xfrm>
-            <a:off x="420000" y="4580000"/>
-            <a:ext cx="11300000" cy="420000"/>
-          </a:xfrm>
-          <a:prstGeom prst="rect">
-            <a:avLst/>
-          </a:prstGeom>
-          <a:noFill/>
-        </p:spPr>
-        <p:txBody>
-          <a:bodyPr wrap="square" anchor="t" lIns="45720" tIns="22860" rIns="45720" bIns="22860"/>
+          <p:cNvPr id="63" name="n63"/>
+          <p:cNvSpPr txBox="1"/>
+          <p:nvPr/>
+        </p:nvSpPr>
+        <p:spPr>
+          <a:xfrm>
+            <a:off x="420000" y="4370000"/>
+            <a:ext cx="11300000" cy="330000"/>
+          </a:xfrm>
+          <a:prstGeom prst="rect">
+            <a:avLst/>
+          </a:prstGeom>
+          <a:noFill/>
+        </p:spPr>
+        <p:txBody>
+          <a:bodyPr wrap="square" anchor="t" lIns="45720" tIns="8000" rIns="45720" bIns="8000"/>
           <a:lstStyle/>
           <a:p>
             <a:pPr algn="l"/>
@@ -5455,7 +6395,7 @@
                 </a:solidFill>
                 <a:latin typeface="Calibri" pitchFamily="34" charset="0"/>
               </a:rPr>
-              <a:t xml:space="preserve">5 / 12</a:t>
+              <a:t xml:space="preserve">5 / 14</a:t>
             </a:r>
           </a:p>
         </p:txBody>
@@ -6011,22 +6951,22 @@
       </p:sp>
       <p:sp>
         <p:nvSpPr>
-          <p:cNvPr id="60" name="t60"/>
+          <p:cNvPr id="60" name="n60"/>
           <p:cNvSpPr txBox="1"/>
           <p:nvPr/>
         </p:nvSpPr>
         <p:spPr>
           <a:xfrm>
             <a:off x="420000" y="3200000"/>
-            <a:ext cx="11300000" cy="420000"/>
-          </a:xfrm>
-          <a:prstGeom prst="rect">
-            <a:avLst/>
-          </a:prstGeom>
-          <a:noFill/>
-        </p:spPr>
-        <p:txBody>
-          <a:bodyPr wrap="square" anchor="t" lIns="45720" tIns="22860" rIns="45720" bIns="22860"/>
+            <a:ext cx="11300000" cy="330000"/>
+          </a:xfrm>
+          <a:prstGeom prst="rect">
+            <a:avLst/>
+          </a:prstGeom>
+          <a:noFill/>
+        </p:spPr>
+        <p:txBody>
+          <a:bodyPr wrap="square" anchor="t" lIns="45720" tIns="8000" rIns="45720" bIns="8000"/>
           <a:lstStyle/>
           <a:p>
             <a:pPr algn="l"/>
@@ -6044,22 +6984,22 @@
       </p:sp>
       <p:sp>
         <p:nvSpPr>
-          <p:cNvPr id="61" name="t61"/>
-          <p:cNvSpPr txBox="1"/>
-          <p:nvPr/>
-        </p:nvSpPr>
-        <p:spPr>
-          <a:xfrm>
-            <a:off x="420000" y="3660000"/>
-            <a:ext cx="11300000" cy="420000"/>
-          </a:xfrm>
-          <a:prstGeom prst="rect">
-            <a:avLst/>
-          </a:prstGeom>
-          <a:noFill/>
-        </p:spPr>
-        <p:txBody>
-          <a:bodyPr wrap="square" anchor="t" lIns="45720" tIns="22860" rIns="45720" bIns="22860"/>
+          <p:cNvPr id="61" name="n61"/>
+          <p:cNvSpPr txBox="1"/>
+          <p:nvPr/>
+        </p:nvSpPr>
+        <p:spPr>
+          <a:xfrm>
+            <a:off x="420000" y="3590000"/>
+            <a:ext cx="11300000" cy="330000"/>
+          </a:xfrm>
+          <a:prstGeom prst="rect">
+            <a:avLst/>
+          </a:prstGeom>
+          <a:noFill/>
+        </p:spPr>
+        <p:txBody>
+          <a:bodyPr wrap="square" anchor="t" lIns="45720" tIns="8000" rIns="45720" bIns="8000"/>
           <a:lstStyle/>
           <a:p>
             <a:pPr algn="l"/>
@@ -6077,22 +7017,22 @@
       </p:sp>
       <p:sp>
         <p:nvSpPr>
-          <p:cNvPr id="62" name="t62"/>
-          <p:cNvSpPr txBox="1"/>
-          <p:nvPr/>
-        </p:nvSpPr>
-        <p:spPr>
-          <a:xfrm>
-            <a:off x="420000" y="4120000"/>
-            <a:ext cx="11300000" cy="420000"/>
-          </a:xfrm>
-          <a:prstGeom prst="rect">
-            <a:avLst/>
-          </a:prstGeom>
-          <a:noFill/>
-        </p:spPr>
-        <p:txBody>
-          <a:bodyPr wrap="square" anchor="t" lIns="45720" tIns="22860" rIns="45720" bIns="22860"/>
+          <p:cNvPr id="62" name="n62"/>
+          <p:cNvSpPr txBox="1"/>
+          <p:nvPr/>
+        </p:nvSpPr>
+        <p:spPr>
+          <a:xfrm>
+            <a:off x="420000" y="3980000"/>
+            <a:ext cx="11300000" cy="330000"/>
+          </a:xfrm>
+          <a:prstGeom prst="rect">
+            <a:avLst/>
+          </a:prstGeom>
+          <a:noFill/>
+        </p:spPr>
+        <p:txBody>
+          <a:bodyPr wrap="square" anchor="t" lIns="45720" tIns="8000" rIns="45720" bIns="8000"/>
           <a:lstStyle/>
           <a:p>
             <a:pPr algn="l"/>
@@ -6110,22 +7050,22 @@
       </p:sp>
       <p:sp>
         <p:nvSpPr>
-          <p:cNvPr id="63" name="t63"/>
-          <p:cNvSpPr txBox="1"/>
-          <p:nvPr/>
-        </p:nvSpPr>
-        <p:spPr>
-          <a:xfrm>
-            <a:off x="420000" y="4580000"/>
-            <a:ext cx="11300000" cy="420000"/>
-          </a:xfrm>
-          <a:prstGeom prst="rect">
-            <a:avLst/>
-          </a:prstGeom>
-          <a:noFill/>
-        </p:spPr>
-        <p:txBody>
-          <a:bodyPr wrap="square" anchor="t" lIns="45720" tIns="22860" rIns="45720" bIns="22860"/>
+          <p:cNvPr id="63" name="n63"/>
+          <p:cNvSpPr txBox="1"/>
+          <p:nvPr/>
+        </p:nvSpPr>
+        <p:spPr>
+          <a:xfrm>
+            <a:off x="420000" y="4370000"/>
+            <a:ext cx="11300000" cy="330000"/>
+          </a:xfrm>
+          <a:prstGeom prst="rect">
+            <a:avLst/>
+          </a:prstGeom>
+          <a:noFill/>
+        </p:spPr>
+        <p:txBody>
+          <a:bodyPr wrap="square" anchor="t" lIns="45720" tIns="8000" rIns="45720" bIns="8000"/>
           <a:lstStyle/>
           <a:p>
             <a:pPr algn="l"/>
@@ -6233,7 +7173,7 @@
                 </a:solidFill>
                 <a:latin typeface="Calibri" pitchFamily="34" charset="0"/>
               </a:rPr>
-              <a:t xml:space="preserve">6 / 12</a:t>
+              <a:t xml:space="preserve">6 / 14</a:t>
             </a:r>
           </a:p>
         </p:txBody>
@@ -6789,22 +7729,22 @@
       </p:sp>
       <p:sp>
         <p:nvSpPr>
-          <p:cNvPr id="60" name="t60"/>
+          <p:cNvPr id="60" name="n60"/>
           <p:cNvSpPr txBox="1"/>
           <p:nvPr/>
         </p:nvSpPr>
         <p:spPr>
           <a:xfrm>
             <a:off x="420000" y="3200000"/>
-            <a:ext cx="11300000" cy="420000"/>
-          </a:xfrm>
-          <a:prstGeom prst="rect">
-            <a:avLst/>
-          </a:prstGeom>
-          <a:noFill/>
-        </p:spPr>
-        <p:txBody>
-          <a:bodyPr wrap="square" anchor="t" lIns="45720" tIns="22860" rIns="45720" bIns="22860"/>
+            <a:ext cx="11300000" cy="330000"/>
+          </a:xfrm>
+          <a:prstGeom prst="rect">
+            <a:avLst/>
+          </a:prstGeom>
+          <a:noFill/>
+        </p:spPr>
+        <p:txBody>
+          <a:bodyPr wrap="square" anchor="t" lIns="45720" tIns="8000" rIns="45720" bIns="8000"/>
           <a:lstStyle/>
           <a:p>
             <a:pPr algn="l"/>
@@ -6822,22 +7762,22 @@
       </p:sp>
       <p:sp>
         <p:nvSpPr>
-          <p:cNvPr id="61" name="t61"/>
-          <p:cNvSpPr txBox="1"/>
-          <p:nvPr/>
-        </p:nvSpPr>
-        <p:spPr>
-          <a:xfrm>
-            <a:off x="420000" y="3660000"/>
-            <a:ext cx="11300000" cy="420000"/>
-          </a:xfrm>
-          <a:prstGeom prst="rect">
-            <a:avLst/>
-          </a:prstGeom>
-          <a:noFill/>
-        </p:spPr>
-        <p:txBody>
-          <a:bodyPr wrap="square" anchor="t" lIns="45720" tIns="22860" rIns="45720" bIns="22860"/>
+          <p:cNvPr id="61" name="n61"/>
+          <p:cNvSpPr txBox="1"/>
+          <p:nvPr/>
+        </p:nvSpPr>
+        <p:spPr>
+          <a:xfrm>
+            <a:off x="420000" y="3590000"/>
+            <a:ext cx="11300000" cy="330000"/>
+          </a:xfrm>
+          <a:prstGeom prst="rect">
+            <a:avLst/>
+          </a:prstGeom>
+          <a:noFill/>
+        </p:spPr>
+        <p:txBody>
+          <a:bodyPr wrap="square" anchor="t" lIns="45720" tIns="8000" rIns="45720" bIns="8000"/>
           <a:lstStyle/>
           <a:p>
             <a:pPr algn="l"/>
@@ -6855,22 +7795,22 @@
       </p:sp>
       <p:sp>
         <p:nvSpPr>
-          <p:cNvPr id="62" name="t62"/>
-          <p:cNvSpPr txBox="1"/>
-          <p:nvPr/>
-        </p:nvSpPr>
-        <p:spPr>
-          <a:xfrm>
-            <a:off x="420000" y="4120000"/>
-            <a:ext cx="11300000" cy="420000"/>
-          </a:xfrm>
-          <a:prstGeom prst="rect">
-            <a:avLst/>
-          </a:prstGeom>
-          <a:noFill/>
-        </p:spPr>
-        <p:txBody>
-          <a:bodyPr wrap="square" anchor="t" lIns="45720" tIns="22860" rIns="45720" bIns="22860"/>
+          <p:cNvPr id="62" name="n62"/>
+          <p:cNvSpPr txBox="1"/>
+          <p:nvPr/>
+        </p:nvSpPr>
+        <p:spPr>
+          <a:xfrm>
+            <a:off x="420000" y="3980000"/>
+            <a:ext cx="11300000" cy="330000"/>
+          </a:xfrm>
+          <a:prstGeom prst="rect">
+            <a:avLst/>
+          </a:prstGeom>
+          <a:noFill/>
+        </p:spPr>
+        <p:txBody>
+          <a:bodyPr wrap="square" anchor="t" lIns="45720" tIns="8000" rIns="45720" bIns="8000"/>
           <a:lstStyle/>
           <a:p>
             <a:pPr algn="l"/>
@@ -6888,22 +7828,22 @@
       </p:sp>
       <p:sp>
         <p:nvSpPr>
-          <p:cNvPr id="63" name="t63"/>
-          <p:cNvSpPr txBox="1"/>
-          <p:nvPr/>
-        </p:nvSpPr>
-        <p:spPr>
-          <a:xfrm>
-            <a:off x="420000" y="4580000"/>
-            <a:ext cx="11300000" cy="420000"/>
-          </a:xfrm>
-          <a:prstGeom prst="rect">
-            <a:avLst/>
-          </a:prstGeom>
-          <a:noFill/>
-        </p:spPr>
-        <p:txBody>
-          <a:bodyPr wrap="square" anchor="t" lIns="45720" tIns="22860" rIns="45720" bIns="22860"/>
+          <p:cNvPr id="63" name="n63"/>
+          <p:cNvSpPr txBox="1"/>
+          <p:nvPr/>
+        </p:nvSpPr>
+        <p:spPr>
+          <a:xfrm>
+            <a:off x="420000" y="4370000"/>
+            <a:ext cx="11300000" cy="330000"/>
+          </a:xfrm>
+          <a:prstGeom prst="rect">
+            <a:avLst/>
+          </a:prstGeom>
+          <a:noFill/>
+        </p:spPr>
+        <p:txBody>
+          <a:bodyPr wrap="square" anchor="t" lIns="45720" tIns="8000" rIns="45720" bIns="8000"/>
           <a:lstStyle/>
           <a:p>
             <a:pPr algn="l"/>
@@ -7011,7 +7951,7 @@
                 </a:solidFill>
                 <a:latin typeface="Calibri" pitchFamily="34" charset="0"/>
               </a:rPr>
-              <a:t xml:space="preserve">7 / 12</a:t>
+              <a:t xml:space="preserve">7 / 14</a:t>
             </a:r>
           </a:p>
         </p:txBody>
@@ -7567,22 +8507,22 @@
       </p:sp>
       <p:sp>
         <p:nvSpPr>
-          <p:cNvPr id="60" name="t60"/>
+          <p:cNvPr id="60" name="n60"/>
           <p:cNvSpPr txBox="1"/>
           <p:nvPr/>
         </p:nvSpPr>
         <p:spPr>
           <a:xfrm>
             <a:off x="420000" y="3200000"/>
-            <a:ext cx="11300000" cy="420000"/>
-          </a:xfrm>
-          <a:prstGeom prst="rect">
-            <a:avLst/>
-          </a:prstGeom>
-          <a:noFill/>
-        </p:spPr>
-        <p:txBody>
-          <a:bodyPr wrap="square" anchor="t" lIns="45720" tIns="22860" rIns="45720" bIns="22860"/>
+            <a:ext cx="11300000" cy="330000"/>
+          </a:xfrm>
+          <a:prstGeom prst="rect">
+            <a:avLst/>
+          </a:prstGeom>
+          <a:noFill/>
+        </p:spPr>
+        <p:txBody>
+          <a:bodyPr wrap="square" anchor="t" lIns="45720" tIns="8000" rIns="45720" bIns="8000"/>
           <a:lstStyle/>
           <a:p>
             <a:pPr algn="l"/>
@@ -7600,22 +8540,22 @@
       </p:sp>
       <p:sp>
         <p:nvSpPr>
-          <p:cNvPr id="61" name="t61"/>
-          <p:cNvSpPr txBox="1"/>
-          <p:nvPr/>
-        </p:nvSpPr>
-        <p:spPr>
-          <a:xfrm>
-            <a:off x="420000" y="3660000"/>
-            <a:ext cx="11300000" cy="420000"/>
-          </a:xfrm>
-          <a:prstGeom prst="rect">
-            <a:avLst/>
-          </a:prstGeom>
-          <a:noFill/>
-        </p:spPr>
-        <p:txBody>
-          <a:bodyPr wrap="square" anchor="t" lIns="45720" tIns="22860" rIns="45720" bIns="22860"/>
+          <p:cNvPr id="61" name="n61"/>
+          <p:cNvSpPr txBox="1"/>
+          <p:nvPr/>
+        </p:nvSpPr>
+        <p:spPr>
+          <a:xfrm>
+            <a:off x="420000" y="3590000"/>
+            <a:ext cx="11300000" cy="330000"/>
+          </a:xfrm>
+          <a:prstGeom prst="rect">
+            <a:avLst/>
+          </a:prstGeom>
+          <a:noFill/>
+        </p:spPr>
+        <p:txBody>
+          <a:bodyPr wrap="square" anchor="t" lIns="45720" tIns="8000" rIns="45720" bIns="8000"/>
           <a:lstStyle/>
           <a:p>
             <a:pPr algn="l"/>
@@ -7633,22 +8573,22 @@
       </p:sp>
       <p:sp>
         <p:nvSpPr>
-          <p:cNvPr id="62" name="t62"/>
-          <p:cNvSpPr txBox="1"/>
-          <p:nvPr/>
-        </p:nvSpPr>
-        <p:spPr>
-          <a:xfrm>
-            <a:off x="420000" y="4120000"/>
-            <a:ext cx="11300000" cy="420000"/>
-          </a:xfrm>
-          <a:prstGeom prst="rect">
-            <a:avLst/>
-          </a:prstGeom>
-          <a:noFill/>
-        </p:spPr>
-        <p:txBody>
-          <a:bodyPr wrap="square" anchor="t" lIns="45720" tIns="22860" rIns="45720" bIns="22860"/>
+          <p:cNvPr id="62" name="n62"/>
+          <p:cNvSpPr txBox="1"/>
+          <p:nvPr/>
+        </p:nvSpPr>
+        <p:spPr>
+          <a:xfrm>
+            <a:off x="420000" y="3980000"/>
+            <a:ext cx="11300000" cy="330000"/>
+          </a:xfrm>
+          <a:prstGeom prst="rect">
+            <a:avLst/>
+          </a:prstGeom>
+          <a:noFill/>
+        </p:spPr>
+        <p:txBody>
+          <a:bodyPr wrap="square" anchor="t" lIns="45720" tIns="8000" rIns="45720" bIns="8000"/>
           <a:lstStyle/>
           <a:p>
             <a:pPr algn="l"/>
@@ -7666,22 +8606,22 @@
       </p:sp>
       <p:sp>
         <p:nvSpPr>
-          <p:cNvPr id="63" name="t63"/>
-          <p:cNvSpPr txBox="1"/>
-          <p:nvPr/>
-        </p:nvSpPr>
-        <p:spPr>
-          <a:xfrm>
-            <a:off x="420000" y="4580000"/>
-            <a:ext cx="11300000" cy="420000"/>
-          </a:xfrm>
-          <a:prstGeom prst="rect">
-            <a:avLst/>
-          </a:prstGeom>
-          <a:noFill/>
-        </p:spPr>
-        <p:txBody>
-          <a:bodyPr wrap="square" anchor="t" lIns="45720" tIns="22860" rIns="45720" bIns="22860"/>
+          <p:cNvPr id="63" name="n63"/>
+          <p:cNvSpPr txBox="1"/>
+          <p:nvPr/>
+        </p:nvSpPr>
+        <p:spPr>
+          <a:xfrm>
+            <a:off x="420000" y="4370000"/>
+            <a:ext cx="11300000" cy="330000"/>
+          </a:xfrm>
+          <a:prstGeom prst="rect">
+            <a:avLst/>
+          </a:prstGeom>
+          <a:noFill/>
+        </p:spPr>
+        <p:txBody>
+          <a:bodyPr wrap="square" anchor="t" lIns="45720" tIns="8000" rIns="45720" bIns="8000"/>
           <a:lstStyle/>
           <a:p>
             <a:pPr algn="l"/>
@@ -7789,7 +8729,7 @@
                 </a:solidFill>
                 <a:latin typeface="Calibri" pitchFamily="34" charset="0"/>
               </a:rPr>
-              <a:t xml:space="preserve">8 / 12</a:t>
+              <a:t xml:space="preserve">8 / 14</a:t>
             </a:r>
           </a:p>
         </p:txBody>
@@ -8345,22 +9285,22 @@
       </p:sp>
       <p:sp>
         <p:nvSpPr>
-          <p:cNvPr id="60" name="t60"/>
+          <p:cNvPr id="60" name="n60"/>
           <p:cNvSpPr txBox="1"/>
           <p:nvPr/>
         </p:nvSpPr>
         <p:spPr>
           <a:xfrm>
             <a:off x="420000" y="3200000"/>
-            <a:ext cx="11300000" cy="420000"/>
-          </a:xfrm>
-          <a:prstGeom prst="rect">
-            <a:avLst/>
-          </a:prstGeom>
-          <a:noFill/>
-        </p:spPr>
-        <p:txBody>
-          <a:bodyPr wrap="square" anchor="t" lIns="45720" tIns="22860" rIns="45720" bIns="22860"/>
+            <a:ext cx="11300000" cy="330000"/>
+          </a:xfrm>
+          <a:prstGeom prst="rect">
+            <a:avLst/>
+          </a:prstGeom>
+          <a:noFill/>
+        </p:spPr>
+        <p:txBody>
+          <a:bodyPr wrap="square" anchor="t" lIns="45720" tIns="8000" rIns="45720" bIns="8000"/>
           <a:lstStyle/>
           <a:p>
             <a:pPr algn="l"/>
@@ -8378,22 +9318,22 @@
       </p:sp>
       <p:sp>
         <p:nvSpPr>
-          <p:cNvPr id="61" name="t61"/>
-          <p:cNvSpPr txBox="1"/>
-          <p:nvPr/>
-        </p:nvSpPr>
-        <p:spPr>
-          <a:xfrm>
-            <a:off x="420000" y="3660000"/>
-            <a:ext cx="11300000" cy="420000"/>
-          </a:xfrm>
-          <a:prstGeom prst="rect">
-            <a:avLst/>
-          </a:prstGeom>
-          <a:noFill/>
-        </p:spPr>
-        <p:txBody>
-          <a:bodyPr wrap="square" anchor="t" lIns="45720" tIns="22860" rIns="45720" bIns="22860"/>
+          <p:cNvPr id="61" name="n61"/>
+          <p:cNvSpPr txBox="1"/>
+          <p:nvPr/>
+        </p:nvSpPr>
+        <p:spPr>
+          <a:xfrm>
+            <a:off x="420000" y="3590000"/>
+            <a:ext cx="11300000" cy="330000"/>
+          </a:xfrm>
+          <a:prstGeom prst="rect">
+            <a:avLst/>
+          </a:prstGeom>
+          <a:noFill/>
+        </p:spPr>
+        <p:txBody>
+          <a:bodyPr wrap="square" anchor="t" lIns="45720" tIns="8000" rIns="45720" bIns="8000"/>
           <a:lstStyle/>
           <a:p>
             <a:pPr algn="l"/>
@@ -8411,22 +9351,22 @@
       </p:sp>
       <p:sp>
         <p:nvSpPr>
-          <p:cNvPr id="62" name="t62"/>
-          <p:cNvSpPr txBox="1"/>
-          <p:nvPr/>
-        </p:nvSpPr>
-        <p:spPr>
-          <a:xfrm>
-            <a:off x="420000" y="4120000"/>
-            <a:ext cx="11300000" cy="420000"/>
-          </a:xfrm>
-          <a:prstGeom prst="rect">
-            <a:avLst/>
-          </a:prstGeom>
-          <a:noFill/>
-        </p:spPr>
-        <p:txBody>
-          <a:bodyPr wrap="square" anchor="t" lIns="45720" tIns="22860" rIns="45720" bIns="22860"/>
+          <p:cNvPr id="62" name="n62"/>
+          <p:cNvSpPr txBox="1"/>
+          <p:nvPr/>
+        </p:nvSpPr>
+        <p:spPr>
+          <a:xfrm>
+            <a:off x="420000" y="3980000"/>
+            <a:ext cx="11300000" cy="330000"/>
+          </a:xfrm>
+          <a:prstGeom prst="rect">
+            <a:avLst/>
+          </a:prstGeom>
+          <a:noFill/>
+        </p:spPr>
+        <p:txBody>
+          <a:bodyPr wrap="square" anchor="t" lIns="45720" tIns="8000" rIns="45720" bIns="8000"/>
           <a:lstStyle/>
           <a:p>
             <a:pPr algn="l"/>
@@ -8444,22 +9384,22 @@
       </p:sp>
       <p:sp>
         <p:nvSpPr>
-          <p:cNvPr id="63" name="t63"/>
-          <p:cNvSpPr txBox="1"/>
-          <p:nvPr/>
-        </p:nvSpPr>
-        <p:spPr>
-          <a:xfrm>
-            <a:off x="420000" y="4580000"/>
-            <a:ext cx="11300000" cy="420000"/>
-          </a:xfrm>
-          <a:prstGeom prst="rect">
-            <a:avLst/>
-          </a:prstGeom>
-          <a:noFill/>
-        </p:spPr>
-        <p:txBody>
-          <a:bodyPr wrap="square" anchor="t" lIns="45720" tIns="22860" rIns="45720" bIns="22860"/>
+          <p:cNvPr id="63" name="n63"/>
+          <p:cNvSpPr txBox="1"/>
+          <p:nvPr/>
+        </p:nvSpPr>
+        <p:spPr>
+          <a:xfrm>
+            <a:off x="420000" y="4370000"/>
+            <a:ext cx="11300000" cy="330000"/>
+          </a:xfrm>
+          <a:prstGeom prst="rect">
+            <a:avLst/>
+          </a:prstGeom>
+          <a:noFill/>
+        </p:spPr>
+        <p:txBody>
+          <a:bodyPr wrap="square" anchor="t" lIns="45720" tIns="8000" rIns="45720" bIns="8000"/>
           <a:lstStyle/>
           <a:p>
             <a:pPr algn="l"/>
@@ -8567,7 +9507,7 @@
                 </a:solidFill>
                 <a:latin typeface="Calibri" pitchFamily="34" charset="0"/>
               </a:rPr>
-              <a:t xml:space="preserve">9 / 12</a:t>
+              <a:t xml:space="preserve">9 / 14</a:t>
             </a:r>
           </a:p>
         </p:txBody>

</xml_diff>